<commit_message>
feat(workflow): implement Phase 9 template catalog alignment, explicit executable metadata, and scope-bounded generic workflow publication rules
</commit_message>
<xml_diff>
--- a/AGI_Architecture_Meeting_Deck.pptx
+++ b/AGI_Architecture_Meeting_Deck.pptx
@@ -2,21 +2,21 @@
 <file path=ppt/presentation.xml><?xml version="1.0" encoding="utf-8"?>
 <p:presentation xmlns:p="http://schemas.openxmlformats.org/presentationml/2006/main">
   <p:sldMasterIdLst>
-    <p:sldMasterId xmlns:r="http://schemas.openxmlformats.org/officeDocument/2006/relationships" id="2147483648" r:id="R32c658c6c7e04add"/>
+    <p:sldMasterId xmlns:r="http://schemas.openxmlformats.org/officeDocument/2006/relationships" id="2147483648" r:id="R549f87eadd2244ff"/>
   </p:sldMasterIdLst>
   <p:notesMasterIdLst>
-    <p:notesMasterId xmlns:r="http://schemas.openxmlformats.org/officeDocument/2006/relationships" r:id="R8ede5b2d3e4e478e"/>
+    <p:notesMasterId xmlns:r="http://schemas.openxmlformats.org/officeDocument/2006/relationships" r:id="R0d4dbcf055074549"/>
   </p:notesMasterIdLst>
   <p:sldIdLst>
-    <p:sldId xmlns:r="http://schemas.openxmlformats.org/officeDocument/2006/relationships" id="256" r:id="Rf134d49b45b54860"/>
-    <p:sldId xmlns:r="http://schemas.openxmlformats.org/officeDocument/2006/relationships" id="257" r:id="Rf8ed89991f854e29"/>
-    <p:sldId xmlns:r="http://schemas.openxmlformats.org/officeDocument/2006/relationships" id="258" r:id="Rd45c741efcb14bb8"/>
-    <p:sldId xmlns:r="http://schemas.openxmlformats.org/officeDocument/2006/relationships" id="259" r:id="R234e5da6067a4249"/>
-    <p:sldId xmlns:r="http://schemas.openxmlformats.org/officeDocument/2006/relationships" id="260" r:id="R7e61710af4ae45e8"/>
-    <p:sldId xmlns:r="http://schemas.openxmlformats.org/officeDocument/2006/relationships" id="261" r:id="R8eeaabc7b57045a7"/>
-    <p:sldId xmlns:r="http://schemas.openxmlformats.org/officeDocument/2006/relationships" id="262" r:id="R8d5d353192c84900"/>
-    <p:sldId xmlns:r="http://schemas.openxmlformats.org/officeDocument/2006/relationships" id="263" r:id="Raa62a628c24b4907"/>
-    <p:sldId xmlns:r="http://schemas.openxmlformats.org/officeDocument/2006/relationships" id="264" r:id="R8fa1c702a331458c"/>
+    <p:sldId xmlns:r="http://schemas.openxmlformats.org/officeDocument/2006/relationships" id="256" r:id="Rbfa6a2432b214ab5"/>
+    <p:sldId xmlns:r="http://schemas.openxmlformats.org/officeDocument/2006/relationships" id="257" r:id="R752eaa6d18c8422d"/>
+    <p:sldId xmlns:r="http://schemas.openxmlformats.org/officeDocument/2006/relationships" id="258" r:id="R1f08b33aea5a449c"/>
+    <p:sldId xmlns:r="http://schemas.openxmlformats.org/officeDocument/2006/relationships" id="259" r:id="R73156f09ebf24c8e"/>
+    <p:sldId xmlns:r="http://schemas.openxmlformats.org/officeDocument/2006/relationships" id="260" r:id="Rf3c46d0f25164487"/>
+    <p:sldId xmlns:r="http://schemas.openxmlformats.org/officeDocument/2006/relationships" id="261" r:id="R07e63a6548f74210"/>
+    <p:sldId xmlns:r="http://schemas.openxmlformats.org/officeDocument/2006/relationships" id="262" r:id="Rd3d159ba76a1469b"/>
+    <p:sldId xmlns:r="http://schemas.openxmlformats.org/officeDocument/2006/relationships" id="263" r:id="R8760ba9772ba4491"/>
+    <p:sldId xmlns:r="http://schemas.openxmlformats.org/officeDocument/2006/relationships" id="264" r:id="R6089a69daf1445fd"/>
   </p:sldIdLst>
   <p:sldSz cx="12192000" cy="6858000"/>
   <p:notesSz cx="6858000" cy="9144000"/>
@@ -1303,7 +1303,7 @@
   </p:cSld>
   <p:clrMap bg1="lt1" tx1="dk1" bg2="lt2" tx2="dk2" accent1="accent1" accent2="accent2" accent3="accent3" accent4="accent4" accent5="accent5" accent6="accent6" hlink="hlink" folHlink="folHlink"/>
   <p:sldLayoutIdLst>
-    <p:sldLayoutId xmlns:r="http://schemas.openxmlformats.org/officeDocument/2006/relationships" id="2147483649" r:id="R5efae4f22689431d"/>
+    <p:sldLayoutId xmlns:r="http://schemas.openxmlformats.org/officeDocument/2006/relationships" id="2147483649" r:id="Re676cc6fd84d4b4a"/>
   </p:sldLayoutIdLst>
   <p:txStyles>
     <p:titleStyle>
@@ -1854,7 +1854,7 @@
           <p:cNvPr id="12" name="">
             <a:extLst xmlns:a="http://schemas.openxmlformats.org/drawingml/2006/main">
               <a:ext uri="{FF2B5EF4-FFF2-40B4-BE49-F238E27FC236}">
-                <a16:creationId xmlns:a16="http://schemas.microsoft.com/office/drawing/2014/main" id="{5762ABAB-65E3-4BD9-8A02-D7FCC215DD8E}"/>
+                <a16:creationId xmlns:a16="http://schemas.microsoft.com/office/drawing/2014/main" id="{FF1D1D34-B7A9-4441-A6C0-9E36F0D1A4C6}"/>
               </a:ext>
             </a:extLst>
           </p:cNvPr>
@@ -1885,7 +1885,7 @@
           <p:cNvPr id="2" name="">
             <a:extLst xmlns:a="http://schemas.openxmlformats.org/drawingml/2006/main">
               <a:ext uri="{FF2B5EF4-FFF2-40B4-BE49-F238E27FC236}">
-                <a16:creationId xmlns:a16="http://schemas.microsoft.com/office/drawing/2014/main" id="{6E816177-21F9-454A-A7E3-F4F4B962A591}"/>
+                <a16:creationId xmlns:a16="http://schemas.microsoft.com/office/drawing/2014/main" id="{FCA4A121-72EC-4092-94A5-737061E58207}"/>
               </a:ext>
             </a:extLst>
           </p:cNvPr>
@@ -1918,7 +1918,7 @@
           <p:cNvPr id="3" name="">
             <a:extLst xmlns:a="http://schemas.openxmlformats.org/drawingml/2006/main">
               <a:ext uri="{FF2B5EF4-FFF2-40B4-BE49-F238E27FC236}">
-                <a16:creationId xmlns:a16="http://schemas.microsoft.com/office/drawing/2014/main" id="{5A551146-32EB-455C-A4C8-8A7F27FC7586}"/>
+                <a16:creationId xmlns:a16="http://schemas.microsoft.com/office/drawing/2014/main" id="{575E1F7C-DD0F-4D7E-9881-1822C3CE655E}"/>
               </a:ext>
             </a:extLst>
           </p:cNvPr>
@@ -1953,7 +1953,7 @@
           <p:cNvPr id="4" name="">
             <a:extLst xmlns:a="http://schemas.openxmlformats.org/drawingml/2006/main">
               <a:ext uri="{FF2B5EF4-FFF2-40B4-BE49-F238E27FC236}">
-                <a16:creationId xmlns:a16="http://schemas.microsoft.com/office/drawing/2014/main" id="{2C549B33-5F25-427F-9EEF-0BC812F63DF4}"/>
+                <a16:creationId xmlns:a16="http://schemas.microsoft.com/office/drawing/2014/main" id="{7444025D-DCD9-4E0C-B6AE-702047B9B1D7}"/>
               </a:ext>
             </a:extLst>
           </p:cNvPr>
@@ -1988,7 +1988,7 @@
           <p:cNvPr id="5" name="">
             <a:extLst xmlns:a="http://schemas.openxmlformats.org/drawingml/2006/main">
               <a:ext uri="{FF2B5EF4-FFF2-40B4-BE49-F238E27FC236}">
-                <a16:creationId xmlns:a16="http://schemas.microsoft.com/office/drawing/2014/main" id="{54E41F78-B8A2-4EC1-9C4B-DFED3486324A}"/>
+                <a16:creationId xmlns:a16="http://schemas.microsoft.com/office/drawing/2014/main" id="{FF5A861D-C5F0-43DA-801A-35E7DC0B5195}"/>
               </a:ext>
             </a:extLst>
           </p:cNvPr>
@@ -2023,7 +2023,7 @@
           <p:cNvPr id="6" name="">
             <a:extLst xmlns:a="http://schemas.openxmlformats.org/drawingml/2006/main">
               <a:ext uri="{FF2B5EF4-FFF2-40B4-BE49-F238E27FC236}">
-                <a16:creationId xmlns:a16="http://schemas.microsoft.com/office/drawing/2014/main" id="{8775F846-06F0-4721-9A17-CE4A03B3CB93}"/>
+                <a16:creationId xmlns:a16="http://schemas.microsoft.com/office/drawing/2014/main" id="{EFE9782C-0336-466A-AD4E-E8B6B97B8FF8}"/>
               </a:ext>
             </a:extLst>
           </p:cNvPr>
@@ -2079,7 +2079,7 @@
           <p:cNvPr id="7" name="">
             <a:extLst xmlns:a="http://schemas.openxmlformats.org/drawingml/2006/main">
               <a:ext uri="{FF2B5EF4-FFF2-40B4-BE49-F238E27FC236}">
-                <a16:creationId xmlns:a16="http://schemas.microsoft.com/office/drawing/2014/main" id="{60903FB3-A6C6-43F0-BA67-91CD24D1DD64}"/>
+                <a16:creationId xmlns:a16="http://schemas.microsoft.com/office/drawing/2014/main" id="{0B6A3E2A-7932-490C-BBD9-B265A133978C}"/>
               </a:ext>
             </a:extLst>
           </p:cNvPr>
@@ -2146,7 +2146,7 @@
           <p:cNvPr id="8" name="">
             <a:extLst xmlns:a="http://schemas.openxmlformats.org/drawingml/2006/main">
               <a:ext uri="{FF2B5EF4-FFF2-40B4-BE49-F238E27FC236}">
-                <a16:creationId xmlns:a16="http://schemas.microsoft.com/office/drawing/2014/main" id="{BA2FF106-30A0-43CA-B8F1-082FD32A7267}"/>
+                <a16:creationId xmlns:a16="http://schemas.microsoft.com/office/drawing/2014/main" id="{788458AE-B88C-4C28-B647-5BF1F19E6D1F}"/>
               </a:ext>
             </a:extLst>
           </p:cNvPr>
@@ -2196,7 +2196,7 @@
           <p:cNvPr id="9" name="">
             <a:extLst xmlns:a="http://schemas.openxmlformats.org/drawingml/2006/main">
               <a:ext uri="{FF2B5EF4-FFF2-40B4-BE49-F238E27FC236}">
-                <a16:creationId xmlns:a16="http://schemas.microsoft.com/office/drawing/2014/main" id="{BB8A9D4B-FB56-40E7-8921-2DF357EDEA4F}"/>
+                <a16:creationId xmlns:a16="http://schemas.microsoft.com/office/drawing/2014/main" id="{62564563-C5B8-48D4-8C54-22838380094C}"/>
               </a:ext>
             </a:extLst>
           </p:cNvPr>
@@ -2246,7 +2246,7 @@
           <p:cNvPr id="10" name="">
             <a:extLst xmlns:a="http://schemas.openxmlformats.org/drawingml/2006/main">
               <a:ext uri="{FF2B5EF4-FFF2-40B4-BE49-F238E27FC236}">
-                <a16:creationId xmlns:a16="http://schemas.microsoft.com/office/drawing/2014/main" id="{3CBD2E2B-5791-4B4C-A523-7565AFBE6ABA}"/>
+                <a16:creationId xmlns:a16="http://schemas.microsoft.com/office/drawing/2014/main" id="{57F6C6F4-57F6-4BA2-AC33-08BE74162FD1}"/>
               </a:ext>
             </a:extLst>
           </p:cNvPr>
@@ -2296,7 +2296,7 @@
           <p:cNvPr id="11" name="">
             <a:extLst xmlns:a="http://schemas.openxmlformats.org/drawingml/2006/main">
               <a:ext uri="{FF2B5EF4-FFF2-40B4-BE49-F238E27FC236}">
-                <a16:creationId xmlns:a16="http://schemas.microsoft.com/office/drawing/2014/main" id="{6CE623CD-E098-4E70-B084-780CB395574E}"/>
+                <a16:creationId xmlns:a16="http://schemas.microsoft.com/office/drawing/2014/main" id="{F1B4ADB5-C6FF-48C0-801C-3A2E11673662}"/>
               </a:ext>
             </a:extLst>
           </p:cNvPr>
@@ -2361,7 +2361,7 @@
     </p:spTree>
     <p:extLst>
       <p:ext uri="{BB962C8B-B14F-4D97-AF65-F5344CB8AC3E}">
-        <p14:creationId xmlns:p14="http://schemas.microsoft.com/office/powerpoint/2010/main" val="1855351831"/>
+        <p14:creationId xmlns:p14="http://schemas.microsoft.com/office/powerpoint/2010/main" val="2109587600"/>
       </p:ext>
     </p:extLst>
   </p:cSld>
@@ -2392,7 +2392,7 @@
           <p:cNvPr id="27" name="">
             <a:extLst xmlns:a="http://schemas.openxmlformats.org/drawingml/2006/main">
               <a:ext uri="{FF2B5EF4-FFF2-40B4-BE49-F238E27FC236}">
-                <a16:creationId xmlns:a16="http://schemas.microsoft.com/office/drawing/2014/main" id="{1630F88C-D539-4CE0-B9E8-9119BBC79792}"/>
+                <a16:creationId xmlns:a16="http://schemas.microsoft.com/office/drawing/2014/main" id="{1A4AAC72-02C0-48FC-9C33-92366F73298B}"/>
               </a:ext>
             </a:extLst>
           </p:cNvPr>
@@ -2448,7 +2448,7 @@
           <p:cNvPr id="2" name="">
             <a:extLst xmlns:a="http://schemas.openxmlformats.org/drawingml/2006/main">
               <a:ext uri="{FF2B5EF4-FFF2-40B4-BE49-F238E27FC236}">
-                <a16:creationId xmlns:a16="http://schemas.microsoft.com/office/drawing/2014/main" id="{E3D7469A-5A2A-4C8B-991B-0FD467452EA9}"/>
+                <a16:creationId xmlns:a16="http://schemas.microsoft.com/office/drawing/2014/main" id="{BC890AB5-B578-43D2-9841-2B4AC53E93D3}"/>
               </a:ext>
             </a:extLst>
           </p:cNvPr>
@@ -2498,7 +2498,7 @@
           <p:cNvPr id="3" name="">
             <a:extLst xmlns:a="http://schemas.openxmlformats.org/drawingml/2006/main">
               <a:ext uri="{FF2B5EF4-FFF2-40B4-BE49-F238E27FC236}">
-                <a16:creationId xmlns:a16="http://schemas.microsoft.com/office/drawing/2014/main" id="{F3B24A39-D938-4EF0-89D5-DB5239F0474D}"/>
+                <a16:creationId xmlns:a16="http://schemas.microsoft.com/office/drawing/2014/main" id="{D4FF4370-3134-4189-9276-092756178051}"/>
               </a:ext>
             </a:extLst>
           </p:cNvPr>
@@ -2548,7 +2548,7 @@
           <p:cNvPr id="4" name="">
             <a:extLst xmlns:a="http://schemas.openxmlformats.org/drawingml/2006/main">
               <a:ext uri="{FF2B5EF4-FFF2-40B4-BE49-F238E27FC236}">
-                <a16:creationId xmlns:a16="http://schemas.microsoft.com/office/drawing/2014/main" id="{93A56857-1734-462E-9569-AD0B89C66CBB}"/>
+                <a16:creationId xmlns:a16="http://schemas.microsoft.com/office/drawing/2014/main" id="{18A5EA16-711D-43C3-9A20-3303B0A0A06A}"/>
               </a:ext>
             </a:extLst>
           </p:cNvPr>
@@ -2598,7 +2598,7 @@
           <p:cNvPr id="5" name="">
             <a:extLst xmlns:a="http://schemas.openxmlformats.org/drawingml/2006/main">
               <a:ext uri="{FF2B5EF4-FFF2-40B4-BE49-F238E27FC236}">
-                <a16:creationId xmlns:a16="http://schemas.microsoft.com/office/drawing/2014/main" id="{6C1CE527-E65E-4C0B-8DD3-D71EBC756A12}"/>
+                <a16:creationId xmlns:a16="http://schemas.microsoft.com/office/drawing/2014/main" id="{BE97C790-617E-495B-B23E-D1943313C46C}"/>
               </a:ext>
             </a:extLst>
           </p:cNvPr>
@@ -2648,7 +2648,7 @@
           <p:cNvPr id="6" name="">
             <a:extLst xmlns:a="http://schemas.openxmlformats.org/drawingml/2006/main">
               <a:ext uri="{FF2B5EF4-FFF2-40B4-BE49-F238E27FC236}">
-                <a16:creationId xmlns:a16="http://schemas.microsoft.com/office/drawing/2014/main" id="{E8AA1621-4F51-413A-9A2B-3CF9F5A91F37}"/>
+                <a16:creationId xmlns:a16="http://schemas.microsoft.com/office/drawing/2014/main" id="{96BFABBB-0718-458A-909F-775E33A19677}"/>
               </a:ext>
             </a:extLst>
           </p:cNvPr>
@@ -2689,7 +2689,7 @@
           <p:cNvPr id="7" name="">
             <a:extLst xmlns:a="http://schemas.openxmlformats.org/drawingml/2006/main">
               <a:ext uri="{FF2B5EF4-FFF2-40B4-BE49-F238E27FC236}">
-                <a16:creationId xmlns:a16="http://schemas.microsoft.com/office/drawing/2014/main" id="{0D4FC5B1-0A53-4DDD-9694-D2B1ED42258A}"/>
+                <a16:creationId xmlns:a16="http://schemas.microsoft.com/office/drawing/2014/main" id="{99F18417-B213-4AFD-998B-7BCF1F00B2C6}"/>
               </a:ext>
             </a:extLst>
           </p:cNvPr>
@@ -2724,7 +2724,7 @@
           <p:cNvPr id="8" name="">
             <a:extLst xmlns:a="http://schemas.openxmlformats.org/drawingml/2006/main">
               <a:ext uri="{FF2B5EF4-FFF2-40B4-BE49-F238E27FC236}">
-                <a16:creationId xmlns:a16="http://schemas.microsoft.com/office/drawing/2014/main" id="{392C02B4-13C3-4CA4-AFEC-BF8D1F52C029}"/>
+                <a16:creationId xmlns:a16="http://schemas.microsoft.com/office/drawing/2014/main" id="{FBD483C7-04BF-4317-9633-2D2C59BD5A08}"/>
               </a:ext>
             </a:extLst>
           </p:cNvPr>
@@ -2774,7 +2774,7 @@
           <p:cNvPr id="9" name="">
             <a:extLst xmlns:a="http://schemas.openxmlformats.org/drawingml/2006/main">
               <a:ext uri="{FF2B5EF4-FFF2-40B4-BE49-F238E27FC236}">
-                <a16:creationId xmlns:a16="http://schemas.microsoft.com/office/drawing/2014/main" id="{9897DC32-B05C-45E5-805A-3200DADFE0B2}"/>
+                <a16:creationId xmlns:a16="http://schemas.microsoft.com/office/drawing/2014/main" id="{2C0319E7-8409-4670-A0EB-29A0144D09DD}"/>
               </a:ext>
             </a:extLst>
           </p:cNvPr>
@@ -2824,7 +2824,7 @@
           <p:cNvPr id="10" name="">
             <a:extLst xmlns:a="http://schemas.openxmlformats.org/drawingml/2006/main">
               <a:ext uri="{FF2B5EF4-FFF2-40B4-BE49-F238E27FC236}">
-                <a16:creationId xmlns:a16="http://schemas.microsoft.com/office/drawing/2014/main" id="{C6EB5D1E-DB2C-4615-8E1E-907ABA7435DE}"/>
+                <a16:creationId xmlns:a16="http://schemas.microsoft.com/office/drawing/2014/main" id="{A52CF62E-17AF-40AB-BCD2-800A9B989E65}"/>
               </a:ext>
             </a:extLst>
           </p:cNvPr>
@@ -2874,7 +2874,7 @@
           <p:cNvPr id="11" name="">
             <a:extLst xmlns:a="http://schemas.openxmlformats.org/drawingml/2006/main">
               <a:ext uri="{FF2B5EF4-FFF2-40B4-BE49-F238E27FC236}">
-                <a16:creationId xmlns:a16="http://schemas.microsoft.com/office/drawing/2014/main" id="{846E85AF-7E2F-4C3A-B1E0-F5B4CE7ECF52}"/>
+                <a16:creationId xmlns:a16="http://schemas.microsoft.com/office/drawing/2014/main" id="{0143C1E1-4A9E-4A11-B1D0-D1C06B8CFD4F}"/>
               </a:ext>
             </a:extLst>
           </p:cNvPr>
@@ -2915,7 +2915,7 @@
           <p:cNvPr id="12" name="">
             <a:extLst xmlns:a="http://schemas.openxmlformats.org/drawingml/2006/main">
               <a:ext uri="{FF2B5EF4-FFF2-40B4-BE49-F238E27FC236}">
-                <a16:creationId xmlns:a16="http://schemas.microsoft.com/office/drawing/2014/main" id="{C9F81CB6-0C91-4928-AB79-D660DDE15E74}"/>
+                <a16:creationId xmlns:a16="http://schemas.microsoft.com/office/drawing/2014/main" id="{E23953EE-F903-4C9A-97D3-4A5C74AD616B}"/>
               </a:ext>
             </a:extLst>
           </p:cNvPr>
@@ -2950,7 +2950,7 @@
           <p:cNvPr id="13" name="">
             <a:extLst xmlns:a="http://schemas.openxmlformats.org/drawingml/2006/main">
               <a:ext uri="{FF2B5EF4-FFF2-40B4-BE49-F238E27FC236}">
-                <a16:creationId xmlns:a16="http://schemas.microsoft.com/office/drawing/2014/main" id="{10C43799-EDF3-4AA9-9A27-BF748C68F51B}"/>
+                <a16:creationId xmlns:a16="http://schemas.microsoft.com/office/drawing/2014/main" id="{77701F2A-64BF-440B-8CFE-96E2BFD888F0}"/>
               </a:ext>
             </a:extLst>
           </p:cNvPr>
@@ -3000,7 +3000,7 @@
           <p:cNvPr id="14" name="">
             <a:extLst xmlns:a="http://schemas.openxmlformats.org/drawingml/2006/main">
               <a:ext uri="{FF2B5EF4-FFF2-40B4-BE49-F238E27FC236}">
-                <a16:creationId xmlns:a16="http://schemas.microsoft.com/office/drawing/2014/main" id="{AE71155E-0A2C-45F6-88B6-8ED5C1B3FC5D}"/>
+                <a16:creationId xmlns:a16="http://schemas.microsoft.com/office/drawing/2014/main" id="{30890E99-27EF-463E-83AB-59297F768A94}"/>
               </a:ext>
             </a:extLst>
           </p:cNvPr>
@@ -3050,7 +3050,7 @@
           <p:cNvPr id="15" name="">
             <a:extLst xmlns:a="http://schemas.openxmlformats.org/drawingml/2006/main">
               <a:ext uri="{FF2B5EF4-FFF2-40B4-BE49-F238E27FC236}">
-                <a16:creationId xmlns:a16="http://schemas.microsoft.com/office/drawing/2014/main" id="{BC8C62C6-5C4E-4A63-B992-995F6AEB1B33}"/>
+                <a16:creationId xmlns:a16="http://schemas.microsoft.com/office/drawing/2014/main" id="{17C0BAF9-6326-43F4-B9B1-18D41EFA4B63}"/>
               </a:ext>
             </a:extLst>
           </p:cNvPr>
@@ -3100,7 +3100,7 @@
           <p:cNvPr id="16" name="">
             <a:extLst xmlns:a="http://schemas.openxmlformats.org/drawingml/2006/main">
               <a:ext uri="{FF2B5EF4-FFF2-40B4-BE49-F238E27FC236}">
-                <a16:creationId xmlns:a16="http://schemas.microsoft.com/office/drawing/2014/main" id="{AA3D0EF7-1762-48D1-AD60-98CBFEC7B14E}"/>
+                <a16:creationId xmlns:a16="http://schemas.microsoft.com/office/drawing/2014/main" id="{C64B870C-EADC-436D-A021-177003BF98EA}"/>
               </a:ext>
             </a:extLst>
           </p:cNvPr>
@@ -3141,7 +3141,7 @@
           <p:cNvPr id="17" name="">
             <a:extLst xmlns:a="http://schemas.openxmlformats.org/drawingml/2006/main">
               <a:ext uri="{FF2B5EF4-FFF2-40B4-BE49-F238E27FC236}">
-                <a16:creationId xmlns:a16="http://schemas.microsoft.com/office/drawing/2014/main" id="{A90E7B79-FFCD-40BB-9B9D-BF92E2EF524D}"/>
+                <a16:creationId xmlns:a16="http://schemas.microsoft.com/office/drawing/2014/main" id="{FE770F99-ACC4-4DCB-9B4C-2F2A2916F844}"/>
               </a:ext>
             </a:extLst>
           </p:cNvPr>
@@ -3176,7 +3176,7 @@
           <p:cNvPr id="18" name="">
             <a:extLst xmlns:a="http://schemas.openxmlformats.org/drawingml/2006/main">
               <a:ext uri="{FF2B5EF4-FFF2-40B4-BE49-F238E27FC236}">
-                <a16:creationId xmlns:a16="http://schemas.microsoft.com/office/drawing/2014/main" id="{CF53D825-9B28-4149-9C44-6480FBA0B1EA}"/>
+                <a16:creationId xmlns:a16="http://schemas.microsoft.com/office/drawing/2014/main" id="{1DF31DD0-F146-4BD3-B789-EBE384ACFC6D}"/>
               </a:ext>
             </a:extLst>
           </p:cNvPr>
@@ -3226,7 +3226,7 @@
           <p:cNvPr id="19" name="">
             <a:extLst xmlns:a="http://schemas.openxmlformats.org/drawingml/2006/main">
               <a:ext uri="{FF2B5EF4-FFF2-40B4-BE49-F238E27FC236}">
-                <a16:creationId xmlns:a16="http://schemas.microsoft.com/office/drawing/2014/main" id="{929D3F13-D2BE-4DE7-B99B-497B9C24ED5E}"/>
+                <a16:creationId xmlns:a16="http://schemas.microsoft.com/office/drawing/2014/main" id="{929D398C-47DA-40BA-BEC0-33ED8E3571A3}"/>
               </a:ext>
             </a:extLst>
           </p:cNvPr>
@@ -3276,7 +3276,7 @@
           <p:cNvPr id="20" name="">
             <a:extLst xmlns:a="http://schemas.openxmlformats.org/drawingml/2006/main">
               <a:ext uri="{FF2B5EF4-FFF2-40B4-BE49-F238E27FC236}">
-                <a16:creationId xmlns:a16="http://schemas.microsoft.com/office/drawing/2014/main" id="{ADD9739D-75EF-4B58-849B-0EB016A4030F}"/>
+                <a16:creationId xmlns:a16="http://schemas.microsoft.com/office/drawing/2014/main" id="{AF6EE87D-9FD4-44E5-9D48-EFA321909257}"/>
               </a:ext>
             </a:extLst>
           </p:cNvPr>
@@ -3326,7 +3326,7 @@
           <p:cNvPr id="21" name="">
             <a:extLst xmlns:a="http://schemas.openxmlformats.org/drawingml/2006/main">
               <a:ext uri="{FF2B5EF4-FFF2-40B4-BE49-F238E27FC236}">
-                <a16:creationId xmlns:a16="http://schemas.microsoft.com/office/drawing/2014/main" id="{598B1623-5990-4B33-A836-69E9B25F3DA4}"/>
+                <a16:creationId xmlns:a16="http://schemas.microsoft.com/office/drawing/2014/main" id="{B28275C9-346E-4FF7-93DB-50318EFDFD8C}"/>
               </a:ext>
             </a:extLst>
           </p:cNvPr>
@@ -3367,7 +3367,7 @@
           <p:cNvPr id="22" name="">
             <a:extLst xmlns:a="http://schemas.openxmlformats.org/drawingml/2006/main">
               <a:ext uri="{FF2B5EF4-FFF2-40B4-BE49-F238E27FC236}">
-                <a16:creationId xmlns:a16="http://schemas.microsoft.com/office/drawing/2014/main" id="{84A47BD9-5073-4149-ABCF-E88AD6787127}"/>
+                <a16:creationId xmlns:a16="http://schemas.microsoft.com/office/drawing/2014/main" id="{87E0362C-73ED-4EF4-B548-64ABB533B680}"/>
               </a:ext>
             </a:extLst>
           </p:cNvPr>
@@ -3402,7 +3402,7 @@
           <p:cNvPr id="23" name="">
             <a:extLst xmlns:a="http://schemas.openxmlformats.org/drawingml/2006/main">
               <a:ext uri="{FF2B5EF4-FFF2-40B4-BE49-F238E27FC236}">
-                <a16:creationId xmlns:a16="http://schemas.microsoft.com/office/drawing/2014/main" id="{CC5F8390-3AEB-45CF-B4FA-886163816AB8}"/>
+                <a16:creationId xmlns:a16="http://schemas.microsoft.com/office/drawing/2014/main" id="{86840E28-961B-44D0-A18D-BB61D40A5AF3}"/>
               </a:ext>
             </a:extLst>
           </p:cNvPr>
@@ -3452,7 +3452,7 @@
           <p:cNvPr id="24" name="">
             <a:extLst xmlns:a="http://schemas.openxmlformats.org/drawingml/2006/main">
               <a:ext uri="{FF2B5EF4-FFF2-40B4-BE49-F238E27FC236}">
-                <a16:creationId xmlns:a16="http://schemas.microsoft.com/office/drawing/2014/main" id="{1CD4F5DB-C3FE-4D20-8D76-C3DC49E5E871}"/>
+                <a16:creationId xmlns:a16="http://schemas.microsoft.com/office/drawing/2014/main" id="{030B0B3D-10E9-4F89-9FF6-CE975AA6EAAA}"/>
               </a:ext>
             </a:extLst>
           </p:cNvPr>
@@ -3502,7 +3502,7 @@
           <p:cNvPr id="25" name="">
             <a:extLst xmlns:a="http://schemas.openxmlformats.org/drawingml/2006/main">
               <a:ext uri="{FF2B5EF4-FFF2-40B4-BE49-F238E27FC236}">
-                <a16:creationId xmlns:a16="http://schemas.microsoft.com/office/drawing/2014/main" id="{5C2DE33A-B67D-44C5-98A2-C0D615087CF2}"/>
+                <a16:creationId xmlns:a16="http://schemas.microsoft.com/office/drawing/2014/main" id="{07E8B7C5-F1EA-4AA7-AD5F-BE1E5614E387}"/>
               </a:ext>
             </a:extLst>
           </p:cNvPr>
@@ -3552,7 +3552,7 @@
           <p:cNvPr id="26" name="">
             <a:extLst xmlns:a="http://schemas.openxmlformats.org/drawingml/2006/main">
               <a:ext uri="{FF2B5EF4-FFF2-40B4-BE49-F238E27FC236}">
-                <a16:creationId xmlns:a16="http://schemas.microsoft.com/office/drawing/2014/main" id="{99461087-44B6-4A81-8E5E-C70F5A6AB9DE}"/>
+                <a16:creationId xmlns:a16="http://schemas.microsoft.com/office/drawing/2014/main" id="{1628A322-AD05-4F7D-A0D3-0E80961BA3C2}"/>
               </a:ext>
             </a:extLst>
           </p:cNvPr>
@@ -3600,7 +3600,7 @@
     </p:spTree>
     <p:extLst>
       <p:ext uri="{BB962C8B-B14F-4D97-AF65-F5344CB8AC3E}">
-        <p14:creationId xmlns:p14="http://schemas.microsoft.com/office/powerpoint/2010/main" val="1986711196"/>
+        <p14:creationId xmlns:p14="http://schemas.microsoft.com/office/powerpoint/2010/main" val="1344809705"/>
       </p:ext>
     </p:extLst>
   </p:cSld>
@@ -3631,7 +3631,7 @@
           <p:cNvPr id="20" name="">
             <a:extLst xmlns:a="http://schemas.openxmlformats.org/drawingml/2006/main">
               <a:ext uri="{FF2B5EF4-FFF2-40B4-BE49-F238E27FC236}">
-                <a16:creationId xmlns:a16="http://schemas.microsoft.com/office/drawing/2014/main" id="{B3206E0F-DEE0-4505-AD4A-AA6099A926E0}"/>
+                <a16:creationId xmlns:a16="http://schemas.microsoft.com/office/drawing/2014/main" id="{FA1D5A2B-0B6C-41B8-B2CD-1A204ED49DE1}"/>
               </a:ext>
             </a:extLst>
           </p:cNvPr>
@@ -3687,7 +3687,7 @@
           <p:cNvPr id="2" name="">
             <a:extLst xmlns:a="http://schemas.openxmlformats.org/drawingml/2006/main">
               <a:ext uri="{FF2B5EF4-FFF2-40B4-BE49-F238E27FC236}">
-                <a16:creationId xmlns:a16="http://schemas.microsoft.com/office/drawing/2014/main" id="{5FB462C1-1FFD-4F19-8994-7D9F5C077208}"/>
+                <a16:creationId xmlns:a16="http://schemas.microsoft.com/office/drawing/2014/main" id="{76EEAE0C-AB6E-4ED4-849D-C610C048A7B3}"/>
               </a:ext>
             </a:extLst>
           </p:cNvPr>
@@ -3737,7 +3737,7 @@
           <p:cNvPr id="3" name="">
             <a:extLst xmlns:a="http://schemas.openxmlformats.org/drawingml/2006/main">
               <a:ext uri="{FF2B5EF4-FFF2-40B4-BE49-F238E27FC236}">
-                <a16:creationId xmlns:a16="http://schemas.microsoft.com/office/drawing/2014/main" id="{1F5429BF-7CF0-4691-B376-955EFB624557}"/>
+                <a16:creationId xmlns:a16="http://schemas.microsoft.com/office/drawing/2014/main" id="{AF9B9E11-0421-4273-AD52-89EE91C4FE91}"/>
               </a:ext>
             </a:extLst>
           </p:cNvPr>
@@ -3787,7 +3787,7 @@
           <p:cNvPr id="4" name="">
             <a:extLst xmlns:a="http://schemas.openxmlformats.org/drawingml/2006/main">
               <a:ext uri="{FF2B5EF4-FFF2-40B4-BE49-F238E27FC236}">
-                <a16:creationId xmlns:a16="http://schemas.microsoft.com/office/drawing/2014/main" id="{F2209E9A-6C5B-4B72-8F94-1E87B9C82A27}"/>
+                <a16:creationId xmlns:a16="http://schemas.microsoft.com/office/drawing/2014/main" id="{9D2D79EA-7021-4AC5-A8B2-34614D4CE8E0}"/>
               </a:ext>
             </a:extLst>
           </p:cNvPr>
@@ -3837,7 +3837,7 @@
           <p:cNvPr id="5" name="">
             <a:extLst xmlns:a="http://schemas.openxmlformats.org/drawingml/2006/main">
               <a:ext uri="{FF2B5EF4-FFF2-40B4-BE49-F238E27FC236}">
-                <a16:creationId xmlns:a16="http://schemas.microsoft.com/office/drawing/2014/main" id="{B85921F4-099C-4C75-A984-A9C4AD802D7B}"/>
+                <a16:creationId xmlns:a16="http://schemas.microsoft.com/office/drawing/2014/main" id="{DC73EF53-EE7F-407E-8242-5F8E2189C0A8}"/>
               </a:ext>
             </a:extLst>
           </p:cNvPr>
@@ -3887,7 +3887,7 @@
           <p:cNvPr id="6" name="">
             <a:extLst xmlns:a="http://schemas.openxmlformats.org/drawingml/2006/main">
               <a:ext uri="{FF2B5EF4-FFF2-40B4-BE49-F238E27FC236}">
-                <a16:creationId xmlns:a16="http://schemas.microsoft.com/office/drawing/2014/main" id="{3C958238-C1BF-4B85-A545-CA0A23CC559A}"/>
+                <a16:creationId xmlns:a16="http://schemas.microsoft.com/office/drawing/2014/main" id="{52D25C91-9114-4A4F-864E-32AECA3982BA}"/>
               </a:ext>
             </a:extLst>
           </p:cNvPr>
@@ -3960,7 +3960,7 @@
           <p:cNvPr id="7" name="">
             <a:extLst xmlns:a="http://schemas.openxmlformats.org/drawingml/2006/main">
               <a:ext uri="{FF2B5EF4-FFF2-40B4-BE49-F238E27FC236}">
-                <a16:creationId xmlns:a16="http://schemas.microsoft.com/office/drawing/2014/main" id="{66F93CD9-2880-4601-B012-90D723FD29C0}"/>
+                <a16:creationId xmlns:a16="http://schemas.microsoft.com/office/drawing/2014/main" id="{209B711D-FC8B-4C6F-A53E-5AEA0A369F4A}"/>
               </a:ext>
             </a:extLst>
           </p:cNvPr>
@@ -4033,7 +4033,7 @@
           <p:cNvPr id="8" name="">
             <a:extLst xmlns:a="http://schemas.openxmlformats.org/drawingml/2006/main">
               <a:ext uri="{FF2B5EF4-FFF2-40B4-BE49-F238E27FC236}">
-                <a16:creationId xmlns:a16="http://schemas.microsoft.com/office/drawing/2014/main" id="{43401C64-4B1D-4C05-8052-196FA079F9B8}"/>
+                <a16:creationId xmlns:a16="http://schemas.microsoft.com/office/drawing/2014/main" id="{82768968-7D6A-459D-AD0F-9E46CA749C76}"/>
               </a:ext>
             </a:extLst>
           </p:cNvPr>
@@ -4112,7 +4112,7 @@
           <p:cNvPr id="9" name="">
             <a:extLst xmlns:a="http://schemas.openxmlformats.org/drawingml/2006/main">
               <a:ext uri="{FF2B5EF4-FFF2-40B4-BE49-F238E27FC236}">
-                <a16:creationId xmlns:a16="http://schemas.microsoft.com/office/drawing/2014/main" id="{3933D740-6540-41B4-9FAF-CBD6168AB9FC}"/>
+                <a16:creationId xmlns:a16="http://schemas.microsoft.com/office/drawing/2014/main" id="{BD9AD8CD-369F-495C-99B1-8DD7C5F0F976}"/>
               </a:ext>
             </a:extLst>
           </p:cNvPr>
@@ -4191,7 +4191,7 @@
           <p:cNvPr id="10" name="">
             <a:extLst xmlns:a="http://schemas.openxmlformats.org/drawingml/2006/main">
               <a:ext uri="{FF2B5EF4-FFF2-40B4-BE49-F238E27FC236}">
-                <a16:creationId xmlns:a16="http://schemas.microsoft.com/office/drawing/2014/main" id="{84D05F1B-A148-4A55-AC60-50DB183D8B75}"/>
+                <a16:creationId xmlns:a16="http://schemas.microsoft.com/office/drawing/2014/main" id="{042D6A19-92E3-470C-913C-7AD8C6F495B9}"/>
               </a:ext>
             </a:extLst>
           </p:cNvPr>
@@ -4298,7 +4298,7 @@
               <a:srgbClr val="3D8DFF"/>
             </a:solidFill>
             <a:prstDash val="solid"/>
-            <a:headEnd type="arrow" w="sm" len="sm"/>
+            <a:tailEnd type="arrow" w="sm" len="sm"/>
           </a:ln>
         </p:spPr>
       </p:cxnSp>
@@ -4324,7 +4324,7 @@
               <a:srgbClr val="3D8DFF"/>
             </a:solidFill>
             <a:prstDash val="solid"/>
-            <a:headEnd type="arrow" w="sm" len="sm"/>
+            <a:tailEnd type="arrow" w="sm" len="sm"/>
           </a:ln>
         </p:spPr>
       </p:cxnSp>
@@ -4350,7 +4350,7 @@
               <a:srgbClr val="3D8DFF"/>
             </a:solidFill>
             <a:prstDash val="solid"/>
-            <a:headEnd type="arrow" w="sm" len="sm"/>
+            <a:tailEnd type="arrow" w="sm" len="sm"/>
           </a:ln>
         </p:spPr>
       </p:cxnSp>
@@ -4376,7 +4376,7 @@
               <a:srgbClr val="3D8DFF"/>
             </a:solidFill>
             <a:prstDash val="solid"/>
-            <a:headEnd type="arrow" w="sm" len="sm"/>
+            <a:tailEnd type="arrow" w="sm" len="sm"/>
           </a:ln>
         </p:spPr>
       </p:cxnSp>
@@ -4385,7 +4385,7 @@
           <p:cNvPr id="15" name="">
             <a:extLst xmlns:a="http://schemas.openxmlformats.org/drawingml/2006/main">
               <a:ext uri="{FF2B5EF4-FFF2-40B4-BE49-F238E27FC236}">
-                <a16:creationId xmlns:a16="http://schemas.microsoft.com/office/drawing/2014/main" id="{5A0B7C72-6D6C-494D-8DB6-4F2706F88276}"/>
+                <a16:creationId xmlns:a16="http://schemas.microsoft.com/office/drawing/2014/main" id="{0A5B4104-B04C-4141-A1FD-23AD99B73737}"/>
               </a:ext>
             </a:extLst>
           </p:cNvPr>
@@ -4458,7 +4458,7 @@
           <p:cNvPr id="16" name="">
             <a:extLst xmlns:a="http://schemas.openxmlformats.org/drawingml/2006/main">
               <a:ext uri="{FF2B5EF4-FFF2-40B4-BE49-F238E27FC236}">
-                <a16:creationId xmlns:a16="http://schemas.microsoft.com/office/drawing/2014/main" id="{9FB6DBAB-266A-43F5-9403-37B0D5829679}"/>
+                <a16:creationId xmlns:a16="http://schemas.microsoft.com/office/drawing/2014/main" id="{4A099B9F-A3AC-4964-A995-04D0638C5B47}"/>
               </a:ext>
             </a:extLst>
           </p:cNvPr>
@@ -4548,7 +4548,7 @@
               <a:srgbClr val="91A6B8"/>
             </a:solidFill>
             <a:prstDash val="dash"/>
-            <a:headEnd type="arrow" w="sm" len="sm"/>
+            <a:tailEnd type="arrow" w="sm" len="sm"/>
           </a:ln>
         </p:spPr>
       </p:cxnSp>
@@ -4574,7 +4574,7 @@
               <a:srgbClr val="91A6B8"/>
             </a:solidFill>
             <a:prstDash val="dash"/>
-            <a:headEnd type="arrow" w="sm" len="sm"/>
+            <a:tailEnd type="arrow" w="sm" len="sm"/>
           </a:ln>
         </p:spPr>
       </p:cxnSp>
@@ -4583,7 +4583,7 @@
           <p:cNvPr id="19" name="">
             <a:extLst xmlns:a="http://schemas.openxmlformats.org/drawingml/2006/main">
               <a:ext uri="{FF2B5EF4-FFF2-40B4-BE49-F238E27FC236}">
-                <a16:creationId xmlns:a16="http://schemas.microsoft.com/office/drawing/2014/main" id="{75DCC361-EBED-464E-8765-D7501EB8009F}"/>
+                <a16:creationId xmlns:a16="http://schemas.microsoft.com/office/drawing/2014/main" id="{38642446-7A2B-43AE-9672-E250830FE815}"/>
               </a:ext>
             </a:extLst>
           </p:cNvPr>
@@ -4631,7 +4631,7 @@
     </p:spTree>
     <p:extLst>
       <p:ext uri="{BB962C8B-B14F-4D97-AF65-F5344CB8AC3E}">
-        <p14:creationId xmlns:p14="http://schemas.microsoft.com/office/powerpoint/2010/main" val="1028300362"/>
+        <p14:creationId xmlns:p14="http://schemas.microsoft.com/office/powerpoint/2010/main" val="1187838678"/>
       </p:ext>
     </p:extLst>
   </p:cSld>
@@ -4662,7 +4662,7 @@
           <p:cNvPr id="37" name="">
             <a:extLst xmlns:a="http://schemas.openxmlformats.org/drawingml/2006/main">
               <a:ext uri="{FF2B5EF4-FFF2-40B4-BE49-F238E27FC236}">
-                <a16:creationId xmlns:a16="http://schemas.microsoft.com/office/drawing/2014/main" id="{4AEC4FC7-9424-450A-ABA1-E17E9FE650FF}"/>
+                <a16:creationId xmlns:a16="http://schemas.microsoft.com/office/drawing/2014/main" id="{935CC9DF-7692-41E2-893D-6CB031421A82}"/>
               </a:ext>
             </a:extLst>
           </p:cNvPr>
@@ -4718,7 +4718,7 @@
           <p:cNvPr id="2" name="">
             <a:extLst xmlns:a="http://schemas.openxmlformats.org/drawingml/2006/main">
               <a:ext uri="{FF2B5EF4-FFF2-40B4-BE49-F238E27FC236}">
-                <a16:creationId xmlns:a16="http://schemas.microsoft.com/office/drawing/2014/main" id="{09435263-82F5-4C43-86BF-8E41E155F3D1}"/>
+                <a16:creationId xmlns:a16="http://schemas.microsoft.com/office/drawing/2014/main" id="{701BF470-A20D-48F3-AE46-5EB9D6EBBE6B}"/>
               </a:ext>
             </a:extLst>
           </p:cNvPr>
@@ -4768,7 +4768,7 @@
           <p:cNvPr id="3" name="">
             <a:extLst xmlns:a="http://schemas.openxmlformats.org/drawingml/2006/main">
               <a:ext uri="{FF2B5EF4-FFF2-40B4-BE49-F238E27FC236}">
-                <a16:creationId xmlns:a16="http://schemas.microsoft.com/office/drawing/2014/main" id="{5C5FEB8D-C354-4920-A281-A5B08C6F1AF1}"/>
+                <a16:creationId xmlns:a16="http://schemas.microsoft.com/office/drawing/2014/main" id="{5C60ABC0-82A4-4359-84F6-8949A3F00B39}"/>
               </a:ext>
             </a:extLst>
           </p:cNvPr>
@@ -4818,7 +4818,7 @@
           <p:cNvPr id="4" name="">
             <a:extLst xmlns:a="http://schemas.openxmlformats.org/drawingml/2006/main">
               <a:ext uri="{FF2B5EF4-FFF2-40B4-BE49-F238E27FC236}">
-                <a16:creationId xmlns:a16="http://schemas.microsoft.com/office/drawing/2014/main" id="{99B46656-1872-436D-99D9-64C1BE33B8F0}"/>
+                <a16:creationId xmlns:a16="http://schemas.microsoft.com/office/drawing/2014/main" id="{9BDA6330-1154-4553-928B-7D22E9280E19}"/>
               </a:ext>
             </a:extLst>
           </p:cNvPr>
@@ -4868,7 +4868,7 @@
           <p:cNvPr id="5" name="">
             <a:extLst xmlns:a="http://schemas.openxmlformats.org/drawingml/2006/main">
               <a:ext uri="{FF2B5EF4-FFF2-40B4-BE49-F238E27FC236}">
-                <a16:creationId xmlns:a16="http://schemas.microsoft.com/office/drawing/2014/main" id="{3C80A12C-E059-4619-95E9-DCA15BD3C517}"/>
+                <a16:creationId xmlns:a16="http://schemas.microsoft.com/office/drawing/2014/main" id="{3DB7745F-7B47-4E4B-81ED-FFB35759AA11}"/>
               </a:ext>
             </a:extLst>
           </p:cNvPr>
@@ -4918,7 +4918,7 @@
           <p:cNvPr id="6" name="">
             <a:extLst xmlns:a="http://schemas.openxmlformats.org/drawingml/2006/main">
               <a:ext uri="{FF2B5EF4-FFF2-40B4-BE49-F238E27FC236}">
-                <a16:creationId xmlns:a16="http://schemas.microsoft.com/office/drawing/2014/main" id="{24DD8F52-38DA-4C68-A490-D2AFB0CD4CBB}"/>
+                <a16:creationId xmlns:a16="http://schemas.microsoft.com/office/drawing/2014/main" id="{6C7BAADD-8429-4901-8A27-DD9B9743A02C}"/>
               </a:ext>
             </a:extLst>
           </p:cNvPr>
@@ -4953,7 +4953,7 @@
           <p:cNvPr id="7" name="">
             <a:extLst xmlns:a="http://schemas.openxmlformats.org/drawingml/2006/main">
               <a:ext uri="{FF2B5EF4-FFF2-40B4-BE49-F238E27FC236}">
-                <a16:creationId xmlns:a16="http://schemas.microsoft.com/office/drawing/2014/main" id="{B4B48572-1485-4FC2-8727-B167B8B0EF38}"/>
+                <a16:creationId xmlns:a16="http://schemas.microsoft.com/office/drawing/2014/main" id="{A4457BEF-B587-4067-8DEE-BAC6E27C241C}"/>
               </a:ext>
             </a:extLst>
           </p:cNvPr>
@@ -5003,7 +5003,7 @@
           <p:cNvPr id="8" name="">
             <a:extLst xmlns:a="http://schemas.openxmlformats.org/drawingml/2006/main">
               <a:ext uri="{FF2B5EF4-FFF2-40B4-BE49-F238E27FC236}">
-                <a16:creationId xmlns:a16="http://schemas.microsoft.com/office/drawing/2014/main" id="{D9FB5E99-EAE3-4DE4-83B7-040A1E4927FB}"/>
+                <a16:creationId xmlns:a16="http://schemas.microsoft.com/office/drawing/2014/main" id="{D80BB3A6-8727-493E-8A40-A0DDBC05AEC2}"/>
               </a:ext>
             </a:extLst>
           </p:cNvPr>
@@ -5053,7 +5053,7 @@
           <p:cNvPr id="9" name="">
             <a:extLst xmlns:a="http://schemas.openxmlformats.org/drawingml/2006/main">
               <a:ext uri="{FF2B5EF4-FFF2-40B4-BE49-F238E27FC236}">
-                <a16:creationId xmlns:a16="http://schemas.microsoft.com/office/drawing/2014/main" id="{6AF319B9-6BDB-4F10-B404-ED98986FEFFD}"/>
+                <a16:creationId xmlns:a16="http://schemas.microsoft.com/office/drawing/2014/main" id="{8EF6F95A-DA7A-4FEB-B04A-283745948688}"/>
               </a:ext>
             </a:extLst>
           </p:cNvPr>
@@ -5103,7 +5103,7 @@
           <p:cNvPr id="10" name="">
             <a:extLst xmlns:a="http://schemas.openxmlformats.org/drawingml/2006/main">
               <a:ext uri="{FF2B5EF4-FFF2-40B4-BE49-F238E27FC236}">
-                <a16:creationId xmlns:a16="http://schemas.microsoft.com/office/drawing/2014/main" id="{E5F03776-8028-45AD-9AE1-C648E81A67E2}"/>
+                <a16:creationId xmlns:a16="http://schemas.microsoft.com/office/drawing/2014/main" id="{4BBB9FC5-0328-4670-BC2D-16B7813A57A2}"/>
               </a:ext>
             </a:extLst>
           </p:cNvPr>
@@ -5138,7 +5138,7 @@
           <p:cNvPr id="11" name="">
             <a:extLst xmlns:a="http://schemas.openxmlformats.org/drawingml/2006/main">
               <a:ext uri="{FF2B5EF4-FFF2-40B4-BE49-F238E27FC236}">
-                <a16:creationId xmlns:a16="http://schemas.microsoft.com/office/drawing/2014/main" id="{B0351542-BD6A-4698-9A49-463F5B815770}"/>
+                <a16:creationId xmlns:a16="http://schemas.microsoft.com/office/drawing/2014/main" id="{22048D95-D63B-43A8-BC1A-33FEF9AA23CF}"/>
               </a:ext>
             </a:extLst>
           </p:cNvPr>
@@ -5188,7 +5188,7 @@
           <p:cNvPr id="12" name="">
             <a:extLst xmlns:a="http://schemas.openxmlformats.org/drawingml/2006/main">
               <a:ext uri="{FF2B5EF4-FFF2-40B4-BE49-F238E27FC236}">
-                <a16:creationId xmlns:a16="http://schemas.microsoft.com/office/drawing/2014/main" id="{4B94BDA0-1BB0-46C5-81B5-94A063E02E31}"/>
+                <a16:creationId xmlns:a16="http://schemas.microsoft.com/office/drawing/2014/main" id="{C8D3AE38-E07B-44D5-B55A-1B9207C7FBE7}"/>
               </a:ext>
             </a:extLst>
           </p:cNvPr>
@@ -5238,7 +5238,7 @@
           <p:cNvPr id="13" name="">
             <a:extLst xmlns:a="http://schemas.openxmlformats.org/drawingml/2006/main">
               <a:ext uri="{FF2B5EF4-FFF2-40B4-BE49-F238E27FC236}">
-                <a16:creationId xmlns:a16="http://schemas.microsoft.com/office/drawing/2014/main" id="{3E449083-6B7D-4CFB-90F1-B76B3F72D7DF}"/>
+                <a16:creationId xmlns:a16="http://schemas.microsoft.com/office/drawing/2014/main" id="{D74B6016-BA94-4DA5-8230-80FDB428AEE2}"/>
               </a:ext>
             </a:extLst>
           </p:cNvPr>
@@ -5288,7 +5288,7 @@
           <p:cNvPr id="14" name="">
             <a:extLst xmlns:a="http://schemas.openxmlformats.org/drawingml/2006/main">
               <a:ext uri="{FF2B5EF4-FFF2-40B4-BE49-F238E27FC236}">
-                <a16:creationId xmlns:a16="http://schemas.microsoft.com/office/drawing/2014/main" id="{4863B0FF-A7B6-46FC-8B57-79B379229536}"/>
+                <a16:creationId xmlns:a16="http://schemas.microsoft.com/office/drawing/2014/main" id="{252708BE-7EDB-495E-BFB8-579355C6F755}"/>
               </a:ext>
             </a:extLst>
           </p:cNvPr>
@@ -5329,7 +5329,7 @@
           <p:cNvPr id="15" name="">
             <a:extLst xmlns:a="http://schemas.openxmlformats.org/drawingml/2006/main">
               <a:ext uri="{FF2B5EF4-FFF2-40B4-BE49-F238E27FC236}">
-                <a16:creationId xmlns:a16="http://schemas.microsoft.com/office/drawing/2014/main" id="{958ED9D9-D099-4A70-898E-D7BFDC5FE66F}"/>
+                <a16:creationId xmlns:a16="http://schemas.microsoft.com/office/drawing/2014/main" id="{41B53747-AA5D-4A2D-890C-26E5977E9817}"/>
               </a:ext>
             </a:extLst>
           </p:cNvPr>
@@ -5379,7 +5379,7 @@
           <p:cNvPr id="16" name="">
             <a:extLst xmlns:a="http://schemas.openxmlformats.org/drawingml/2006/main">
               <a:ext uri="{FF2B5EF4-FFF2-40B4-BE49-F238E27FC236}">
-                <a16:creationId xmlns:a16="http://schemas.microsoft.com/office/drawing/2014/main" id="{18FDAF83-BB57-435E-BF5D-A3521CA54975}"/>
+                <a16:creationId xmlns:a16="http://schemas.microsoft.com/office/drawing/2014/main" id="{69BB47D7-C90D-461B-9372-938C22A5B559}"/>
               </a:ext>
             </a:extLst>
           </p:cNvPr>
@@ -5429,7 +5429,7 @@
           <p:cNvPr id="17" name="">
             <a:extLst xmlns:a="http://schemas.openxmlformats.org/drawingml/2006/main">
               <a:ext uri="{FF2B5EF4-FFF2-40B4-BE49-F238E27FC236}">
-                <a16:creationId xmlns:a16="http://schemas.microsoft.com/office/drawing/2014/main" id="{4B1F247A-B5E0-4B67-A897-0D33A2689679}"/>
+                <a16:creationId xmlns:a16="http://schemas.microsoft.com/office/drawing/2014/main" id="{E4ADE41C-261F-4DBC-AD81-33584B668CE0}"/>
               </a:ext>
             </a:extLst>
           </p:cNvPr>
@@ -5479,7 +5479,7 @@
           <p:cNvPr id="18" name="">
             <a:extLst xmlns:a="http://schemas.openxmlformats.org/drawingml/2006/main">
               <a:ext uri="{FF2B5EF4-FFF2-40B4-BE49-F238E27FC236}">
-                <a16:creationId xmlns:a16="http://schemas.microsoft.com/office/drawing/2014/main" id="{6126D930-E6E4-4CC6-A860-BC1BC0777583}"/>
+                <a16:creationId xmlns:a16="http://schemas.microsoft.com/office/drawing/2014/main" id="{9834CF50-B6BD-4713-A18D-625EBA02E6B8}"/>
               </a:ext>
             </a:extLst>
           </p:cNvPr>
@@ -5514,7 +5514,7 @@
           <p:cNvPr id="19" name="">
             <a:extLst xmlns:a="http://schemas.openxmlformats.org/drawingml/2006/main">
               <a:ext uri="{FF2B5EF4-FFF2-40B4-BE49-F238E27FC236}">
-                <a16:creationId xmlns:a16="http://schemas.microsoft.com/office/drawing/2014/main" id="{BAE4DEDA-8810-4A4A-A1E0-DA2439634060}"/>
+                <a16:creationId xmlns:a16="http://schemas.microsoft.com/office/drawing/2014/main" id="{B9D0367B-05EC-4B15-8303-3BDDAFD3EAD4}"/>
               </a:ext>
             </a:extLst>
           </p:cNvPr>
@@ -5564,7 +5564,7 @@
           <p:cNvPr id="20" name="">
             <a:extLst xmlns:a="http://schemas.openxmlformats.org/drawingml/2006/main">
               <a:ext uri="{FF2B5EF4-FFF2-40B4-BE49-F238E27FC236}">
-                <a16:creationId xmlns:a16="http://schemas.microsoft.com/office/drawing/2014/main" id="{393E063C-33DE-408F-840F-4B7199EF3695}"/>
+                <a16:creationId xmlns:a16="http://schemas.microsoft.com/office/drawing/2014/main" id="{7945826B-D096-4BB3-B145-C5D8143B2E75}"/>
               </a:ext>
             </a:extLst>
           </p:cNvPr>
@@ -5614,7 +5614,7 @@
           <p:cNvPr id="21" name="">
             <a:extLst xmlns:a="http://schemas.openxmlformats.org/drawingml/2006/main">
               <a:ext uri="{FF2B5EF4-FFF2-40B4-BE49-F238E27FC236}">
-                <a16:creationId xmlns:a16="http://schemas.microsoft.com/office/drawing/2014/main" id="{DEE1BEE8-471E-44CF-8A24-FAEC2314C80F}"/>
+                <a16:creationId xmlns:a16="http://schemas.microsoft.com/office/drawing/2014/main" id="{97EC0B46-3BAC-45F2-B2DB-776F265321E0}"/>
               </a:ext>
             </a:extLst>
           </p:cNvPr>
@@ -5664,7 +5664,7 @@
           <p:cNvPr id="22" name="">
             <a:extLst xmlns:a="http://schemas.openxmlformats.org/drawingml/2006/main">
               <a:ext uri="{FF2B5EF4-FFF2-40B4-BE49-F238E27FC236}">
-                <a16:creationId xmlns:a16="http://schemas.microsoft.com/office/drawing/2014/main" id="{A2957D86-2B6B-4196-AE6D-50BA9BE339CE}"/>
+                <a16:creationId xmlns:a16="http://schemas.microsoft.com/office/drawing/2014/main" id="{F7C6D246-EF4A-480D-AD87-B6E109B322FE}"/>
               </a:ext>
             </a:extLst>
           </p:cNvPr>
@@ -5699,7 +5699,7 @@
           <p:cNvPr id="23" name="">
             <a:extLst xmlns:a="http://schemas.openxmlformats.org/drawingml/2006/main">
               <a:ext uri="{FF2B5EF4-FFF2-40B4-BE49-F238E27FC236}">
-                <a16:creationId xmlns:a16="http://schemas.microsoft.com/office/drawing/2014/main" id="{15D34826-82B0-480D-A077-B1A620CF7E40}"/>
+                <a16:creationId xmlns:a16="http://schemas.microsoft.com/office/drawing/2014/main" id="{0431B561-AA12-4AEB-8560-3341AB194A2F}"/>
               </a:ext>
             </a:extLst>
           </p:cNvPr>
@@ -5749,7 +5749,7 @@
           <p:cNvPr id="24" name="">
             <a:extLst xmlns:a="http://schemas.openxmlformats.org/drawingml/2006/main">
               <a:ext uri="{FF2B5EF4-FFF2-40B4-BE49-F238E27FC236}">
-                <a16:creationId xmlns:a16="http://schemas.microsoft.com/office/drawing/2014/main" id="{7B2F48E6-312D-4507-B82D-10D1E43261A8}"/>
+                <a16:creationId xmlns:a16="http://schemas.microsoft.com/office/drawing/2014/main" id="{79FC2639-39B9-4600-AF17-52A9B65066EF}"/>
               </a:ext>
             </a:extLst>
           </p:cNvPr>
@@ -5799,7 +5799,7 @@
           <p:cNvPr id="25" name="">
             <a:extLst xmlns:a="http://schemas.openxmlformats.org/drawingml/2006/main">
               <a:ext uri="{FF2B5EF4-FFF2-40B4-BE49-F238E27FC236}">
-                <a16:creationId xmlns:a16="http://schemas.microsoft.com/office/drawing/2014/main" id="{A83D18B2-6B8B-4F32-B21A-7869421663D8}"/>
+                <a16:creationId xmlns:a16="http://schemas.microsoft.com/office/drawing/2014/main" id="{B9A1DF41-3B7D-43A6-A5BF-86F0572318F8}"/>
               </a:ext>
             </a:extLst>
           </p:cNvPr>
@@ -5849,7 +5849,7 @@
           <p:cNvPr id="26" name="">
             <a:extLst xmlns:a="http://schemas.openxmlformats.org/drawingml/2006/main">
               <a:ext uri="{FF2B5EF4-FFF2-40B4-BE49-F238E27FC236}">
-                <a16:creationId xmlns:a16="http://schemas.microsoft.com/office/drawing/2014/main" id="{2D15B7D9-E4F4-4076-B879-004736FA6171}"/>
+                <a16:creationId xmlns:a16="http://schemas.microsoft.com/office/drawing/2014/main" id="{F5550312-A8ED-45F7-ABFE-72F14FC59D59}"/>
               </a:ext>
             </a:extLst>
           </p:cNvPr>
@@ -5884,7 +5884,7 @@
           <p:cNvPr id="27" name="">
             <a:extLst xmlns:a="http://schemas.openxmlformats.org/drawingml/2006/main">
               <a:ext uri="{FF2B5EF4-FFF2-40B4-BE49-F238E27FC236}">
-                <a16:creationId xmlns:a16="http://schemas.microsoft.com/office/drawing/2014/main" id="{CEB57EE9-6CAD-45FE-8541-F26701284A93}"/>
+                <a16:creationId xmlns:a16="http://schemas.microsoft.com/office/drawing/2014/main" id="{BDDC9AD4-7DF9-4B4D-8000-2490327C5266}"/>
               </a:ext>
             </a:extLst>
           </p:cNvPr>
@@ -5934,7 +5934,7 @@
           <p:cNvPr id="28" name="">
             <a:extLst xmlns:a="http://schemas.openxmlformats.org/drawingml/2006/main">
               <a:ext uri="{FF2B5EF4-FFF2-40B4-BE49-F238E27FC236}">
-                <a16:creationId xmlns:a16="http://schemas.microsoft.com/office/drawing/2014/main" id="{9B427145-2E77-4298-9055-2FAB37C67669}"/>
+                <a16:creationId xmlns:a16="http://schemas.microsoft.com/office/drawing/2014/main" id="{CD1CBCE9-F15E-4682-896C-842CB75D4292}"/>
               </a:ext>
             </a:extLst>
           </p:cNvPr>
@@ -5984,7 +5984,7 @@
           <p:cNvPr id="29" name="">
             <a:extLst xmlns:a="http://schemas.openxmlformats.org/drawingml/2006/main">
               <a:ext uri="{FF2B5EF4-FFF2-40B4-BE49-F238E27FC236}">
-                <a16:creationId xmlns:a16="http://schemas.microsoft.com/office/drawing/2014/main" id="{49676A19-7347-4B31-8BBF-C991F52479A7}"/>
+                <a16:creationId xmlns:a16="http://schemas.microsoft.com/office/drawing/2014/main" id="{6A1B3A44-8C27-444F-8706-E95FB97E194E}"/>
               </a:ext>
             </a:extLst>
           </p:cNvPr>
@@ -6051,7 +6051,7 @@
               <a:srgbClr val="3D8DFF"/>
             </a:solidFill>
             <a:prstDash val="solid"/>
-            <a:headEnd type="arrow" w="sm" len="sm"/>
+            <a:tailEnd type="arrow" w="sm" len="sm"/>
           </a:ln>
         </p:spPr>
       </p:cxnSp>
@@ -6077,7 +6077,7 @@
               <a:srgbClr val="3D8DFF"/>
             </a:solidFill>
             <a:prstDash val="solid"/>
-            <a:headEnd type="arrow" w="sm" len="sm"/>
+            <a:tailEnd type="arrow" w="sm" len="sm"/>
           </a:ln>
         </p:spPr>
       </p:cxnSp>
@@ -6103,7 +6103,7 @@
               <a:srgbClr val="3D8DFF"/>
             </a:solidFill>
             <a:prstDash val="solid"/>
-            <a:headEnd type="arrow" w="sm" len="sm"/>
+            <a:tailEnd type="arrow" w="sm" len="sm"/>
           </a:ln>
         </p:spPr>
       </p:cxnSp>
@@ -6129,7 +6129,7 @@
               <a:srgbClr val="3D8DFF"/>
             </a:solidFill>
             <a:prstDash val="solid"/>
-            <a:headEnd type="arrow" w="sm" len="sm"/>
+            <a:tailEnd type="arrow" w="sm" len="sm"/>
           </a:ln>
         </p:spPr>
       </p:cxnSp>
@@ -6155,7 +6155,7 @@
               <a:srgbClr val="3D8DFF"/>
             </a:solidFill>
             <a:prstDash val="solid"/>
-            <a:headEnd type="arrow" w="sm" len="sm"/>
+            <a:tailEnd type="arrow" w="sm" len="sm"/>
           </a:ln>
         </p:spPr>
       </p:cxnSp>
@@ -6164,7 +6164,7 @@
           <p:cNvPr id="35" name="">
             <a:extLst xmlns:a="http://schemas.openxmlformats.org/drawingml/2006/main">
               <a:ext uri="{FF2B5EF4-FFF2-40B4-BE49-F238E27FC236}">
-                <a16:creationId xmlns:a16="http://schemas.microsoft.com/office/drawing/2014/main" id="{31B7E5BE-58FB-4147-808B-E6E0F51E6630}"/>
+                <a16:creationId xmlns:a16="http://schemas.microsoft.com/office/drawing/2014/main" id="{05F82750-EBDA-44DE-9894-930E6614A2E7}"/>
               </a:ext>
             </a:extLst>
           </p:cNvPr>
@@ -6199,7 +6199,7 @@
           <p:cNvPr id="36" name="">
             <a:extLst xmlns:a="http://schemas.openxmlformats.org/drawingml/2006/main">
               <a:ext uri="{FF2B5EF4-FFF2-40B4-BE49-F238E27FC236}">
-                <a16:creationId xmlns:a16="http://schemas.microsoft.com/office/drawing/2014/main" id="{CBAB57F7-A663-43E4-A5BA-762900F892B5}"/>
+                <a16:creationId xmlns:a16="http://schemas.microsoft.com/office/drawing/2014/main" id="{7F1377C9-9637-4D6A-8504-B9FBAD1D948F}"/>
               </a:ext>
             </a:extLst>
           </p:cNvPr>
@@ -6247,7 +6247,7 @@
     </p:spTree>
     <p:extLst>
       <p:ext uri="{BB962C8B-B14F-4D97-AF65-F5344CB8AC3E}">
-        <p14:creationId xmlns:p14="http://schemas.microsoft.com/office/powerpoint/2010/main" val="977829090"/>
+        <p14:creationId xmlns:p14="http://schemas.microsoft.com/office/powerpoint/2010/main" val="1721251296"/>
       </p:ext>
     </p:extLst>
   </p:cSld>
@@ -6278,7 +6278,7 @@
           <p:cNvPr id="23" name="">
             <a:extLst xmlns:a="http://schemas.openxmlformats.org/drawingml/2006/main">
               <a:ext uri="{FF2B5EF4-FFF2-40B4-BE49-F238E27FC236}">
-                <a16:creationId xmlns:a16="http://schemas.microsoft.com/office/drawing/2014/main" id="{3EE86A7D-649A-43AA-A412-8C902BC064A9}"/>
+                <a16:creationId xmlns:a16="http://schemas.microsoft.com/office/drawing/2014/main" id="{70A389BF-C15B-4183-A97F-FCB35FC25489}"/>
               </a:ext>
             </a:extLst>
           </p:cNvPr>
@@ -6334,7 +6334,7 @@
           <p:cNvPr id="2" name="">
             <a:extLst xmlns:a="http://schemas.openxmlformats.org/drawingml/2006/main">
               <a:ext uri="{FF2B5EF4-FFF2-40B4-BE49-F238E27FC236}">
-                <a16:creationId xmlns:a16="http://schemas.microsoft.com/office/drawing/2014/main" id="{DB1671DE-10B2-4A0D-8A02-ACC09FEFE73B}"/>
+                <a16:creationId xmlns:a16="http://schemas.microsoft.com/office/drawing/2014/main" id="{42E2E174-5E5A-4127-A795-65D189195BDB}"/>
               </a:ext>
             </a:extLst>
           </p:cNvPr>
@@ -6384,7 +6384,7 @@
           <p:cNvPr id="3" name="">
             <a:extLst xmlns:a="http://schemas.openxmlformats.org/drawingml/2006/main">
               <a:ext uri="{FF2B5EF4-FFF2-40B4-BE49-F238E27FC236}">
-                <a16:creationId xmlns:a16="http://schemas.microsoft.com/office/drawing/2014/main" id="{D33BCA8D-A4F7-45DA-B79A-5CEB1AD9397D}"/>
+                <a16:creationId xmlns:a16="http://schemas.microsoft.com/office/drawing/2014/main" id="{D2FE8731-B07F-4016-A247-7934F912374D}"/>
               </a:ext>
             </a:extLst>
           </p:cNvPr>
@@ -6434,7 +6434,7 @@
           <p:cNvPr id="4" name="">
             <a:extLst xmlns:a="http://schemas.openxmlformats.org/drawingml/2006/main">
               <a:ext uri="{FF2B5EF4-FFF2-40B4-BE49-F238E27FC236}">
-                <a16:creationId xmlns:a16="http://schemas.microsoft.com/office/drawing/2014/main" id="{5D5A448D-819D-4208-B26B-9B702F4D5D28}"/>
+                <a16:creationId xmlns:a16="http://schemas.microsoft.com/office/drawing/2014/main" id="{85FBF6BE-AFF1-408B-91AA-D6A526FC25BA}"/>
               </a:ext>
             </a:extLst>
           </p:cNvPr>
@@ -6484,7 +6484,7 @@
           <p:cNvPr id="5" name="">
             <a:extLst xmlns:a="http://schemas.openxmlformats.org/drawingml/2006/main">
               <a:ext uri="{FF2B5EF4-FFF2-40B4-BE49-F238E27FC236}">
-                <a16:creationId xmlns:a16="http://schemas.microsoft.com/office/drawing/2014/main" id="{FC277619-50B4-4807-A060-C7B2803E4599}"/>
+                <a16:creationId xmlns:a16="http://schemas.microsoft.com/office/drawing/2014/main" id="{240E2ECE-2D9C-4770-9704-A5A7028D3480}"/>
               </a:ext>
             </a:extLst>
           </p:cNvPr>
@@ -6534,7 +6534,7 @@
           <p:cNvPr id="6" name="">
             <a:extLst xmlns:a="http://schemas.openxmlformats.org/drawingml/2006/main">
               <a:ext uri="{FF2B5EF4-FFF2-40B4-BE49-F238E27FC236}">
-                <a16:creationId xmlns:a16="http://schemas.microsoft.com/office/drawing/2014/main" id="{B392F347-E117-4F02-86CF-C981A6D7EDB5}"/>
+                <a16:creationId xmlns:a16="http://schemas.microsoft.com/office/drawing/2014/main" id="{04A1535A-25AE-412E-84B0-668D42D161CB}"/>
               </a:ext>
             </a:extLst>
           </p:cNvPr>
@@ -6575,7 +6575,7 @@
           <p:cNvPr id="7" name="">
             <a:extLst xmlns:a="http://schemas.openxmlformats.org/drawingml/2006/main">
               <a:ext uri="{FF2B5EF4-FFF2-40B4-BE49-F238E27FC236}">
-                <a16:creationId xmlns:a16="http://schemas.microsoft.com/office/drawing/2014/main" id="{3856C192-CCAC-40CA-A161-67AAC9A79988}"/>
+                <a16:creationId xmlns:a16="http://schemas.microsoft.com/office/drawing/2014/main" id="{59ADB743-246C-4037-B5D5-19FFEE09E91F}"/>
               </a:ext>
             </a:extLst>
           </p:cNvPr>
@@ -6616,7 +6616,7 @@
           <p:cNvPr id="8" name="">
             <a:extLst xmlns:a="http://schemas.openxmlformats.org/drawingml/2006/main">
               <a:ext uri="{FF2B5EF4-FFF2-40B4-BE49-F238E27FC236}">
-                <a16:creationId xmlns:a16="http://schemas.microsoft.com/office/drawing/2014/main" id="{F7AE1F24-AA07-43FB-AB13-A2D8B90BD312}"/>
+                <a16:creationId xmlns:a16="http://schemas.microsoft.com/office/drawing/2014/main" id="{C8E19E99-87A2-4397-884B-9740F2788453}"/>
               </a:ext>
             </a:extLst>
           </p:cNvPr>
@@ -6666,7 +6666,7 @@
           <p:cNvPr id="9" name="">
             <a:extLst xmlns:a="http://schemas.openxmlformats.org/drawingml/2006/main">
               <a:ext uri="{FF2B5EF4-FFF2-40B4-BE49-F238E27FC236}">
-                <a16:creationId xmlns:a16="http://schemas.microsoft.com/office/drawing/2014/main" id="{103CC94D-E48F-4870-8874-1F17FDB12E97}"/>
+                <a16:creationId xmlns:a16="http://schemas.microsoft.com/office/drawing/2014/main" id="{9CFD3792-7D2F-4756-9DE9-160916997D47}"/>
               </a:ext>
             </a:extLst>
           </p:cNvPr>
@@ -6716,7 +6716,7 @@
           <p:cNvPr id="10" name="">
             <a:extLst xmlns:a="http://schemas.openxmlformats.org/drawingml/2006/main">
               <a:ext uri="{FF2B5EF4-FFF2-40B4-BE49-F238E27FC236}">
-                <a16:creationId xmlns:a16="http://schemas.microsoft.com/office/drawing/2014/main" id="{34781A41-BE2F-420F-B396-BFDA0D00DDCC}"/>
+                <a16:creationId xmlns:a16="http://schemas.microsoft.com/office/drawing/2014/main" id="{DEEA03E1-B8AC-4759-A0FF-B986E63C84B8}"/>
               </a:ext>
             </a:extLst>
           </p:cNvPr>
@@ -6751,7 +6751,7 @@
           <p:cNvPr id="11" name="">
             <a:extLst xmlns:a="http://schemas.openxmlformats.org/drawingml/2006/main">
               <a:ext uri="{FF2B5EF4-FFF2-40B4-BE49-F238E27FC236}">
-                <a16:creationId xmlns:a16="http://schemas.microsoft.com/office/drawing/2014/main" id="{F36A9D00-49DA-4B75-A152-B17D359863D3}"/>
+                <a16:creationId xmlns:a16="http://schemas.microsoft.com/office/drawing/2014/main" id="{332DA196-4969-4480-B473-E98BF0F687F7}"/>
               </a:ext>
             </a:extLst>
           </p:cNvPr>
@@ -6801,7 +6801,7 @@
           <p:cNvPr id="12" name="">
             <a:extLst xmlns:a="http://schemas.openxmlformats.org/drawingml/2006/main">
               <a:ext uri="{FF2B5EF4-FFF2-40B4-BE49-F238E27FC236}">
-                <a16:creationId xmlns:a16="http://schemas.microsoft.com/office/drawing/2014/main" id="{A6C6D89A-C4C5-4F4A-B32A-AD66C01BF873}"/>
+                <a16:creationId xmlns:a16="http://schemas.microsoft.com/office/drawing/2014/main" id="{CACCB7D7-2DF9-4160-ADCC-C10A407766BF}"/>
               </a:ext>
             </a:extLst>
           </p:cNvPr>
@@ -6836,7 +6836,7 @@
           <p:cNvPr id="13" name="">
             <a:extLst xmlns:a="http://schemas.openxmlformats.org/drawingml/2006/main">
               <a:ext uri="{FF2B5EF4-FFF2-40B4-BE49-F238E27FC236}">
-                <a16:creationId xmlns:a16="http://schemas.microsoft.com/office/drawing/2014/main" id="{C196CCB1-2713-4084-9A87-53841B9A4479}"/>
+                <a16:creationId xmlns:a16="http://schemas.microsoft.com/office/drawing/2014/main" id="{8D415188-776C-43AD-8B9E-F23E22BB41BC}"/>
               </a:ext>
             </a:extLst>
           </p:cNvPr>
@@ -6886,7 +6886,7 @@
           <p:cNvPr id="14" name="">
             <a:extLst xmlns:a="http://schemas.openxmlformats.org/drawingml/2006/main">
               <a:ext uri="{FF2B5EF4-FFF2-40B4-BE49-F238E27FC236}">
-                <a16:creationId xmlns:a16="http://schemas.microsoft.com/office/drawing/2014/main" id="{781EB237-4655-4F2E-A83C-7ABE6BD961D4}"/>
+                <a16:creationId xmlns:a16="http://schemas.microsoft.com/office/drawing/2014/main" id="{F3E5BAFE-03F1-4633-9133-2E303766F882}"/>
               </a:ext>
             </a:extLst>
           </p:cNvPr>
@@ -6921,7 +6921,7 @@
           <p:cNvPr id="15" name="">
             <a:extLst xmlns:a="http://schemas.openxmlformats.org/drawingml/2006/main">
               <a:ext uri="{FF2B5EF4-FFF2-40B4-BE49-F238E27FC236}">
-                <a16:creationId xmlns:a16="http://schemas.microsoft.com/office/drawing/2014/main" id="{F82F5B3E-34F0-4659-942F-6B04104F9919}"/>
+                <a16:creationId xmlns:a16="http://schemas.microsoft.com/office/drawing/2014/main" id="{31996D96-5BB2-48C0-BEDA-5345C58FA56C}"/>
               </a:ext>
             </a:extLst>
           </p:cNvPr>
@@ -6971,7 +6971,7 @@
           <p:cNvPr id="16" name="">
             <a:extLst xmlns:a="http://schemas.openxmlformats.org/drawingml/2006/main">
               <a:ext uri="{FF2B5EF4-FFF2-40B4-BE49-F238E27FC236}">
-                <a16:creationId xmlns:a16="http://schemas.microsoft.com/office/drawing/2014/main" id="{9DAFEACC-2E31-4410-8759-E41294B38A9F}"/>
+                <a16:creationId xmlns:a16="http://schemas.microsoft.com/office/drawing/2014/main" id="{C29F2ABD-8A53-47DA-AE83-1AB2F93575C1}"/>
               </a:ext>
             </a:extLst>
           </p:cNvPr>
@@ -7006,7 +7006,7 @@
           <p:cNvPr id="17" name="">
             <a:extLst xmlns:a="http://schemas.openxmlformats.org/drawingml/2006/main">
               <a:ext uri="{FF2B5EF4-FFF2-40B4-BE49-F238E27FC236}">
-                <a16:creationId xmlns:a16="http://schemas.microsoft.com/office/drawing/2014/main" id="{1DBC5E16-494C-453A-88BC-7F1BC0289A0D}"/>
+                <a16:creationId xmlns:a16="http://schemas.microsoft.com/office/drawing/2014/main" id="{4E90A260-B91A-4EC9-9358-64321D6BA857}"/>
               </a:ext>
             </a:extLst>
           </p:cNvPr>
@@ -7056,7 +7056,7 @@
           <p:cNvPr id="18" name="">
             <a:extLst xmlns:a="http://schemas.openxmlformats.org/drawingml/2006/main">
               <a:ext uri="{FF2B5EF4-FFF2-40B4-BE49-F238E27FC236}">
-                <a16:creationId xmlns:a16="http://schemas.microsoft.com/office/drawing/2014/main" id="{339679AD-7A34-4D25-9DDB-5E550A660C82}"/>
+                <a16:creationId xmlns:a16="http://schemas.microsoft.com/office/drawing/2014/main" id="{F55202C7-D697-4EE3-853C-DDAD6E47394C}"/>
               </a:ext>
             </a:extLst>
           </p:cNvPr>
@@ -7091,7 +7091,7 @@
           <p:cNvPr id="19" name="">
             <a:extLst xmlns:a="http://schemas.openxmlformats.org/drawingml/2006/main">
               <a:ext uri="{FF2B5EF4-FFF2-40B4-BE49-F238E27FC236}">
-                <a16:creationId xmlns:a16="http://schemas.microsoft.com/office/drawing/2014/main" id="{96336E5B-63E9-430D-8CB4-BF090CB92951}"/>
+                <a16:creationId xmlns:a16="http://schemas.microsoft.com/office/drawing/2014/main" id="{2BF86BCA-B8E3-4345-B6D8-9A5F213F64C8}"/>
               </a:ext>
             </a:extLst>
           </p:cNvPr>
@@ -7141,7 +7141,7 @@
           <p:cNvPr id="20" name="">
             <a:extLst xmlns:a="http://schemas.openxmlformats.org/drawingml/2006/main">
               <a:ext uri="{FF2B5EF4-FFF2-40B4-BE49-F238E27FC236}">
-                <a16:creationId xmlns:a16="http://schemas.microsoft.com/office/drawing/2014/main" id="{B366F53D-1D3A-4515-9C3E-4D03AF193857}"/>
+                <a16:creationId xmlns:a16="http://schemas.microsoft.com/office/drawing/2014/main" id="{3439C7D6-FBE1-4C34-94EE-BC14B3AF7107}"/>
               </a:ext>
             </a:extLst>
           </p:cNvPr>
@@ -7176,7 +7176,7 @@
           <p:cNvPr id="21" name="">
             <a:extLst xmlns:a="http://schemas.openxmlformats.org/drawingml/2006/main">
               <a:ext uri="{FF2B5EF4-FFF2-40B4-BE49-F238E27FC236}">
-                <a16:creationId xmlns:a16="http://schemas.microsoft.com/office/drawing/2014/main" id="{FFAB7ED9-0DCB-40EE-87F2-AFAB95FE3FD9}"/>
+                <a16:creationId xmlns:a16="http://schemas.microsoft.com/office/drawing/2014/main" id="{679930BC-4FCB-4AD9-A5E0-954F853E611A}"/>
               </a:ext>
             </a:extLst>
           </p:cNvPr>
@@ -7226,7 +7226,7 @@
           <p:cNvPr id="22" name="">
             <a:extLst xmlns:a="http://schemas.openxmlformats.org/drawingml/2006/main">
               <a:ext uri="{FF2B5EF4-FFF2-40B4-BE49-F238E27FC236}">
-                <a16:creationId xmlns:a16="http://schemas.microsoft.com/office/drawing/2014/main" id="{76D9FEB9-C265-4FC2-948C-F62F135FEA17}"/>
+                <a16:creationId xmlns:a16="http://schemas.microsoft.com/office/drawing/2014/main" id="{91E74193-D48F-484F-809C-BE0F4E865A4D}"/>
               </a:ext>
             </a:extLst>
           </p:cNvPr>
@@ -7274,7 +7274,7 @@
     </p:spTree>
     <p:extLst>
       <p:ext uri="{BB962C8B-B14F-4D97-AF65-F5344CB8AC3E}">
-        <p14:creationId xmlns:p14="http://schemas.microsoft.com/office/powerpoint/2010/main" val="318234155"/>
+        <p14:creationId xmlns:p14="http://schemas.microsoft.com/office/powerpoint/2010/main" val="719458325"/>
       </p:ext>
     </p:extLst>
   </p:cSld>
@@ -7305,7 +7305,7 @@
           <p:cNvPr id="23" name="">
             <a:extLst xmlns:a="http://schemas.openxmlformats.org/drawingml/2006/main">
               <a:ext uri="{FF2B5EF4-FFF2-40B4-BE49-F238E27FC236}">
-                <a16:creationId xmlns:a16="http://schemas.microsoft.com/office/drawing/2014/main" id="{A4420587-59E7-42A2-954B-6392D3B0DBBD}"/>
+                <a16:creationId xmlns:a16="http://schemas.microsoft.com/office/drawing/2014/main" id="{082729AC-ACED-4660-9BA9-6F4C0932D3D9}"/>
               </a:ext>
             </a:extLst>
           </p:cNvPr>
@@ -7361,7 +7361,7 @@
           <p:cNvPr id="2" name="">
             <a:extLst xmlns:a="http://schemas.openxmlformats.org/drawingml/2006/main">
               <a:ext uri="{FF2B5EF4-FFF2-40B4-BE49-F238E27FC236}">
-                <a16:creationId xmlns:a16="http://schemas.microsoft.com/office/drawing/2014/main" id="{6567DEC0-4B07-4F1B-9F8F-080905B9ABB7}"/>
+                <a16:creationId xmlns:a16="http://schemas.microsoft.com/office/drawing/2014/main" id="{6385B401-2FD9-429E-8518-990043B0CB7C}"/>
               </a:ext>
             </a:extLst>
           </p:cNvPr>
@@ -7411,7 +7411,7 @@
           <p:cNvPr id="3" name="">
             <a:extLst xmlns:a="http://schemas.openxmlformats.org/drawingml/2006/main">
               <a:ext uri="{FF2B5EF4-FFF2-40B4-BE49-F238E27FC236}">
-                <a16:creationId xmlns:a16="http://schemas.microsoft.com/office/drawing/2014/main" id="{49B877E5-6F99-4015-B7A5-3683E1233AAE}"/>
+                <a16:creationId xmlns:a16="http://schemas.microsoft.com/office/drawing/2014/main" id="{9F292C64-2BC5-4C88-87DD-06FC38108AF2}"/>
               </a:ext>
             </a:extLst>
           </p:cNvPr>
@@ -7461,7 +7461,7 @@
           <p:cNvPr id="4" name="">
             <a:extLst xmlns:a="http://schemas.openxmlformats.org/drawingml/2006/main">
               <a:ext uri="{FF2B5EF4-FFF2-40B4-BE49-F238E27FC236}">
-                <a16:creationId xmlns:a16="http://schemas.microsoft.com/office/drawing/2014/main" id="{326C7876-2C93-46C0-BA82-E030782D8E73}"/>
+                <a16:creationId xmlns:a16="http://schemas.microsoft.com/office/drawing/2014/main" id="{A6557DA0-6D47-4E6A-B225-C27D73121450}"/>
               </a:ext>
             </a:extLst>
           </p:cNvPr>
@@ -7511,7 +7511,7 @@
           <p:cNvPr id="5" name="">
             <a:extLst xmlns:a="http://schemas.openxmlformats.org/drawingml/2006/main">
               <a:ext uri="{FF2B5EF4-FFF2-40B4-BE49-F238E27FC236}">
-                <a16:creationId xmlns:a16="http://schemas.microsoft.com/office/drawing/2014/main" id="{AC34ADD9-8E40-4268-81F9-F2E140143E73}"/>
+                <a16:creationId xmlns:a16="http://schemas.microsoft.com/office/drawing/2014/main" id="{ED34AA12-3F65-4695-B670-0E8B41389966}"/>
               </a:ext>
             </a:extLst>
           </p:cNvPr>
@@ -7561,7 +7561,7 @@
           <p:cNvPr id="6" name="">
             <a:extLst xmlns:a="http://schemas.openxmlformats.org/drawingml/2006/main">
               <a:ext uri="{FF2B5EF4-FFF2-40B4-BE49-F238E27FC236}">
-                <a16:creationId xmlns:a16="http://schemas.microsoft.com/office/drawing/2014/main" id="{D42B1759-CBB6-4946-AE20-B9EFA0BD8B90}"/>
+                <a16:creationId xmlns:a16="http://schemas.microsoft.com/office/drawing/2014/main" id="{9150F7A3-024F-41AA-8FD5-19C3C353B939}"/>
               </a:ext>
             </a:extLst>
           </p:cNvPr>
@@ -7640,7 +7640,7 @@
           <p:cNvPr id="7" name="">
             <a:extLst xmlns:a="http://schemas.openxmlformats.org/drawingml/2006/main">
               <a:ext uri="{FF2B5EF4-FFF2-40B4-BE49-F238E27FC236}">
-                <a16:creationId xmlns:a16="http://schemas.microsoft.com/office/drawing/2014/main" id="{62BB98EA-19D2-4BAB-A81C-EB149D6C7FE1}"/>
+                <a16:creationId xmlns:a16="http://schemas.microsoft.com/office/drawing/2014/main" id="{73CCA1E5-3B79-4FD4-BFFA-94EF9583BA05}"/>
               </a:ext>
             </a:extLst>
           </p:cNvPr>
@@ -7719,7 +7719,7 @@
           <p:cNvPr id="8" name="">
             <a:extLst xmlns:a="http://schemas.openxmlformats.org/drawingml/2006/main">
               <a:ext uri="{FF2B5EF4-FFF2-40B4-BE49-F238E27FC236}">
-                <a16:creationId xmlns:a16="http://schemas.microsoft.com/office/drawing/2014/main" id="{671BF297-1A77-4BD5-96F6-0C63F8F7B796}"/>
+                <a16:creationId xmlns:a16="http://schemas.microsoft.com/office/drawing/2014/main" id="{481CD4A6-B5AC-4737-A762-B62B1AA7AB51}"/>
               </a:ext>
             </a:extLst>
           </p:cNvPr>
@@ -7798,7 +7798,7 @@
           <p:cNvPr id="9" name="">
             <a:extLst xmlns:a="http://schemas.openxmlformats.org/drawingml/2006/main">
               <a:ext uri="{FF2B5EF4-FFF2-40B4-BE49-F238E27FC236}">
-                <a16:creationId xmlns:a16="http://schemas.microsoft.com/office/drawing/2014/main" id="{C427A71B-CEA9-4489-864C-19427A7D035C}"/>
+                <a16:creationId xmlns:a16="http://schemas.microsoft.com/office/drawing/2014/main" id="{7B1B0245-089C-46DD-8674-AC920EECD675}"/>
               </a:ext>
             </a:extLst>
           </p:cNvPr>
@@ -7894,7 +7894,7 @@
           <p:cNvPr id="10" name="">
             <a:extLst xmlns:a="http://schemas.openxmlformats.org/drawingml/2006/main">
               <a:ext uri="{FF2B5EF4-FFF2-40B4-BE49-F238E27FC236}">
-                <a16:creationId xmlns:a16="http://schemas.microsoft.com/office/drawing/2014/main" id="{6726ADAF-7F01-4F1E-A4D2-677FEC9A9C77}"/>
+                <a16:creationId xmlns:a16="http://schemas.microsoft.com/office/drawing/2014/main" id="{95FB11EF-2A16-4233-81F5-587C9FC17055}"/>
               </a:ext>
             </a:extLst>
           </p:cNvPr>
@@ -8012,7 +8012,7 @@
               <a:srgbClr val="3D8DFF"/>
             </a:solidFill>
             <a:prstDash val="solid"/>
-            <a:headEnd type="arrow" w="sm" len="sm"/>
+            <a:tailEnd type="arrow" w="sm" len="sm"/>
           </a:ln>
         </p:spPr>
       </p:cxnSp>
@@ -8038,7 +8038,7 @@
               <a:srgbClr val="3D8DFF"/>
             </a:solidFill>
             <a:prstDash val="solid"/>
-            <a:headEnd type="arrow" w="sm" len="sm"/>
+            <a:tailEnd type="arrow" w="sm" len="sm"/>
           </a:ln>
         </p:spPr>
       </p:cxnSp>
@@ -8064,7 +8064,7 @@
               <a:srgbClr val="3D8DFF"/>
             </a:solidFill>
             <a:prstDash val="solid"/>
-            <a:headEnd type="arrow" w="sm" len="sm"/>
+            <a:tailEnd type="arrow" w="sm" len="sm"/>
           </a:ln>
         </p:spPr>
       </p:cxnSp>
@@ -8090,7 +8090,7 @@
               <a:srgbClr val="3D8DFF"/>
             </a:solidFill>
             <a:prstDash val="solid"/>
-            <a:headEnd type="arrow" w="sm" len="sm"/>
+            <a:tailEnd type="arrow" w="sm" len="sm"/>
           </a:ln>
         </p:spPr>
       </p:cxnSp>
@@ -8099,7 +8099,7 @@
           <p:cNvPr id="15" name="">
             <a:extLst xmlns:a="http://schemas.openxmlformats.org/drawingml/2006/main">
               <a:ext uri="{FF2B5EF4-FFF2-40B4-BE49-F238E27FC236}">
-                <a16:creationId xmlns:a16="http://schemas.microsoft.com/office/drawing/2014/main" id="{1782705F-B424-4932-869F-C603F8D986E7}"/>
+                <a16:creationId xmlns:a16="http://schemas.microsoft.com/office/drawing/2014/main" id="{6C18F167-C13F-4601-8840-050CE9B7CA24}"/>
               </a:ext>
             </a:extLst>
           </p:cNvPr>
@@ -8172,7 +8172,7 @@
           <p:cNvPr id="16" name="">
             <a:extLst xmlns:a="http://schemas.openxmlformats.org/drawingml/2006/main">
               <a:ext uri="{FF2B5EF4-FFF2-40B4-BE49-F238E27FC236}">
-                <a16:creationId xmlns:a16="http://schemas.microsoft.com/office/drawing/2014/main" id="{B0AE0353-6071-4641-A429-22675B845F6B}"/>
+                <a16:creationId xmlns:a16="http://schemas.microsoft.com/office/drawing/2014/main" id="{515461C4-9783-470E-9ADD-44EBCAFD08D6}"/>
               </a:ext>
             </a:extLst>
           </p:cNvPr>
@@ -8245,7 +8245,7 @@
           <p:cNvPr id="17" name="">
             <a:extLst xmlns:a="http://schemas.openxmlformats.org/drawingml/2006/main">
               <a:ext uri="{FF2B5EF4-FFF2-40B4-BE49-F238E27FC236}">
-                <a16:creationId xmlns:a16="http://schemas.microsoft.com/office/drawing/2014/main" id="{DD6636F4-384D-46AE-A25F-FA35B00270CC}"/>
+                <a16:creationId xmlns:a16="http://schemas.microsoft.com/office/drawing/2014/main" id="{4555958C-38CE-4A68-B8F6-F2A6A8252A8D}"/>
               </a:ext>
             </a:extLst>
           </p:cNvPr>
@@ -8318,7 +8318,7 @@
           <p:cNvPr id="18" name="">
             <a:extLst xmlns:a="http://schemas.openxmlformats.org/drawingml/2006/main">
               <a:ext uri="{FF2B5EF4-FFF2-40B4-BE49-F238E27FC236}">
-                <a16:creationId xmlns:a16="http://schemas.microsoft.com/office/drawing/2014/main" id="{E4567186-2C9B-4225-8BCC-9D2E5021FFFE}"/>
+                <a16:creationId xmlns:a16="http://schemas.microsoft.com/office/drawing/2014/main" id="{50E9273E-54BF-4166-AF2D-71852B06C53B}"/>
               </a:ext>
             </a:extLst>
           </p:cNvPr>
@@ -8408,7 +8408,7 @@
               <a:srgbClr val="3D8DFF"/>
             </a:solidFill>
             <a:prstDash val="solid"/>
-            <a:headEnd type="arrow" w="sm" len="sm"/>
+            <a:tailEnd type="arrow" w="sm" len="sm"/>
           </a:ln>
         </p:spPr>
       </p:cxnSp>
@@ -8434,7 +8434,7 @@
               <a:srgbClr val="3D8DFF"/>
             </a:solidFill>
             <a:prstDash val="solid"/>
-            <a:headEnd type="arrow" w="sm" len="sm"/>
+            <a:tailEnd type="arrow" w="sm" len="sm"/>
           </a:ln>
         </p:spPr>
       </p:cxnSp>
@@ -8460,7 +8460,7 @@
               <a:srgbClr val="3D8DFF"/>
             </a:solidFill>
             <a:prstDash val="solid"/>
-            <a:headEnd type="arrow" w="sm" len="sm"/>
+            <a:tailEnd type="arrow" w="sm" len="sm"/>
           </a:ln>
         </p:spPr>
       </p:cxnSp>
@@ -8486,14 +8486,14 @@
               <a:srgbClr val="3D8DFF"/>
             </a:solidFill>
             <a:prstDash val="solid"/>
-            <a:headEnd type="arrow" w="sm" len="sm"/>
+            <a:tailEnd type="arrow" w="sm" len="sm"/>
           </a:ln>
         </p:spPr>
       </p:cxnSp>
     </p:spTree>
     <p:extLst>
       <p:ext uri="{BB962C8B-B14F-4D97-AF65-F5344CB8AC3E}">
-        <p14:creationId xmlns:p14="http://schemas.microsoft.com/office/powerpoint/2010/main" val="469180262"/>
+        <p14:creationId xmlns:p14="http://schemas.microsoft.com/office/powerpoint/2010/main" val="1042960612"/>
       </p:ext>
     </p:extLst>
   </p:cSld>
@@ -8524,7 +8524,7 @@
           <p:cNvPr id="20" name="">
             <a:extLst xmlns:a="http://schemas.openxmlformats.org/drawingml/2006/main">
               <a:ext uri="{FF2B5EF4-FFF2-40B4-BE49-F238E27FC236}">
-                <a16:creationId xmlns:a16="http://schemas.microsoft.com/office/drawing/2014/main" id="{B1E43BFC-0059-4E34-BFEE-6E69F6DA69D9}"/>
+                <a16:creationId xmlns:a16="http://schemas.microsoft.com/office/drawing/2014/main" id="{B2B287D9-2BA1-400F-AB7B-268E0392A3B7}"/>
               </a:ext>
             </a:extLst>
           </p:cNvPr>
@@ -8580,7 +8580,7 @@
           <p:cNvPr id="2" name="">
             <a:extLst xmlns:a="http://schemas.openxmlformats.org/drawingml/2006/main">
               <a:ext uri="{FF2B5EF4-FFF2-40B4-BE49-F238E27FC236}">
-                <a16:creationId xmlns:a16="http://schemas.microsoft.com/office/drawing/2014/main" id="{C993D424-75E1-48F7-9A8E-9C6F65702877}"/>
+                <a16:creationId xmlns:a16="http://schemas.microsoft.com/office/drawing/2014/main" id="{BC9B65AD-C27F-4B9D-BF3C-251A7F84C188}"/>
               </a:ext>
             </a:extLst>
           </p:cNvPr>
@@ -8630,7 +8630,7 @@
           <p:cNvPr id="3" name="">
             <a:extLst xmlns:a="http://schemas.openxmlformats.org/drawingml/2006/main">
               <a:ext uri="{FF2B5EF4-FFF2-40B4-BE49-F238E27FC236}">
-                <a16:creationId xmlns:a16="http://schemas.microsoft.com/office/drawing/2014/main" id="{556EDCC8-E79E-43C3-84DE-CB5A517BBBE2}"/>
+                <a16:creationId xmlns:a16="http://schemas.microsoft.com/office/drawing/2014/main" id="{5B86422F-4633-45AA-AAC0-C4F21254815B}"/>
               </a:ext>
             </a:extLst>
           </p:cNvPr>
@@ -8680,7 +8680,7 @@
           <p:cNvPr id="4" name="">
             <a:extLst xmlns:a="http://schemas.openxmlformats.org/drawingml/2006/main">
               <a:ext uri="{FF2B5EF4-FFF2-40B4-BE49-F238E27FC236}">
-                <a16:creationId xmlns:a16="http://schemas.microsoft.com/office/drawing/2014/main" id="{C9E4486D-D953-4A43-8B11-74681BB9FE8A}"/>
+                <a16:creationId xmlns:a16="http://schemas.microsoft.com/office/drawing/2014/main" id="{5B948862-197B-440B-82C8-01F02E941167}"/>
               </a:ext>
             </a:extLst>
           </p:cNvPr>
@@ -8730,7 +8730,7 @@
           <p:cNvPr id="5" name="">
             <a:extLst xmlns:a="http://schemas.openxmlformats.org/drawingml/2006/main">
               <a:ext uri="{FF2B5EF4-FFF2-40B4-BE49-F238E27FC236}">
-                <a16:creationId xmlns:a16="http://schemas.microsoft.com/office/drawing/2014/main" id="{B9FAFB78-F2C6-4337-823E-4B5998A593C7}"/>
+                <a16:creationId xmlns:a16="http://schemas.microsoft.com/office/drawing/2014/main" id="{4E7778E5-DA21-4073-B3C1-53679A344B67}"/>
               </a:ext>
             </a:extLst>
           </p:cNvPr>
@@ -8780,7 +8780,7 @@
           <p:cNvPr id="6" name="">
             <a:extLst xmlns:a="http://schemas.openxmlformats.org/drawingml/2006/main">
               <a:ext uri="{FF2B5EF4-FFF2-40B4-BE49-F238E27FC236}">
-                <a16:creationId xmlns:a16="http://schemas.microsoft.com/office/drawing/2014/main" id="{1470831B-2129-4F91-A462-7355ADE2246B}"/>
+                <a16:creationId xmlns:a16="http://schemas.microsoft.com/office/drawing/2014/main" id="{E50E67C7-13EB-41C4-8441-4577BDA55F07}"/>
               </a:ext>
             </a:extLst>
           </p:cNvPr>
@@ -8821,7 +8821,7 @@
           <p:cNvPr id="7" name="">
             <a:extLst xmlns:a="http://schemas.openxmlformats.org/drawingml/2006/main">
               <a:ext uri="{FF2B5EF4-FFF2-40B4-BE49-F238E27FC236}">
-                <a16:creationId xmlns:a16="http://schemas.microsoft.com/office/drawing/2014/main" id="{C02B8553-7A7F-40A0-A276-267F71D69E12}"/>
+                <a16:creationId xmlns:a16="http://schemas.microsoft.com/office/drawing/2014/main" id="{AA325597-F7C7-4B58-B61A-7F50A0F9E3B6}"/>
               </a:ext>
             </a:extLst>
           </p:cNvPr>
@@ -8871,7 +8871,7 @@
           <p:cNvPr id="8" name="">
             <a:extLst xmlns:a="http://schemas.openxmlformats.org/drawingml/2006/main">
               <a:ext uri="{FF2B5EF4-FFF2-40B4-BE49-F238E27FC236}">
-                <a16:creationId xmlns:a16="http://schemas.microsoft.com/office/drawing/2014/main" id="{60732CED-B0BA-490D-8B6E-B643E843E515}"/>
+                <a16:creationId xmlns:a16="http://schemas.microsoft.com/office/drawing/2014/main" id="{5EFCB854-10E8-4625-A664-3C0A5B99D208}"/>
               </a:ext>
             </a:extLst>
           </p:cNvPr>
@@ -8921,7 +8921,7 @@
           <p:cNvPr id="9" name="">
             <a:extLst xmlns:a="http://schemas.openxmlformats.org/drawingml/2006/main">
               <a:ext uri="{FF2B5EF4-FFF2-40B4-BE49-F238E27FC236}">
-                <a16:creationId xmlns:a16="http://schemas.microsoft.com/office/drawing/2014/main" id="{1AF0B177-F0B1-4F59-A546-5D5824C767FE}"/>
+                <a16:creationId xmlns:a16="http://schemas.microsoft.com/office/drawing/2014/main" id="{C22A829B-6C7D-4891-AEEC-BED99B454433}"/>
               </a:ext>
             </a:extLst>
           </p:cNvPr>
@@ -8971,7 +8971,7 @@
           <p:cNvPr id="10" name="">
             <a:extLst xmlns:a="http://schemas.openxmlformats.org/drawingml/2006/main">
               <a:ext uri="{FF2B5EF4-FFF2-40B4-BE49-F238E27FC236}">
-                <a16:creationId xmlns:a16="http://schemas.microsoft.com/office/drawing/2014/main" id="{F5CE6D48-BE80-4A09-A16D-FEB9E8B356AF}"/>
+                <a16:creationId xmlns:a16="http://schemas.microsoft.com/office/drawing/2014/main" id="{13516527-14B8-490D-80AB-DE66CE867AD5}"/>
               </a:ext>
             </a:extLst>
           </p:cNvPr>
@@ -9012,7 +9012,7 @@
           <p:cNvPr id="11" name="">
             <a:extLst xmlns:a="http://schemas.openxmlformats.org/drawingml/2006/main">
               <a:ext uri="{FF2B5EF4-FFF2-40B4-BE49-F238E27FC236}">
-                <a16:creationId xmlns:a16="http://schemas.microsoft.com/office/drawing/2014/main" id="{E1444D8A-65EE-4079-859E-A21B6AE8295B}"/>
+                <a16:creationId xmlns:a16="http://schemas.microsoft.com/office/drawing/2014/main" id="{2DD974A0-7A3B-4C1C-B7F7-28E4F0CFE61D}"/>
               </a:ext>
             </a:extLst>
           </p:cNvPr>
@@ -9062,7 +9062,7 @@
           <p:cNvPr id="12" name="">
             <a:extLst xmlns:a="http://schemas.openxmlformats.org/drawingml/2006/main">
               <a:ext uri="{FF2B5EF4-FFF2-40B4-BE49-F238E27FC236}">
-                <a16:creationId xmlns:a16="http://schemas.microsoft.com/office/drawing/2014/main" id="{45F6FD05-8678-4713-859E-CC39961572F5}"/>
+                <a16:creationId xmlns:a16="http://schemas.microsoft.com/office/drawing/2014/main" id="{A8DB0E99-37B1-48A3-B8A7-6CA88277E26F}"/>
               </a:ext>
             </a:extLst>
           </p:cNvPr>
@@ -9112,7 +9112,7 @@
           <p:cNvPr id="13" name="">
             <a:extLst xmlns:a="http://schemas.openxmlformats.org/drawingml/2006/main">
               <a:ext uri="{FF2B5EF4-FFF2-40B4-BE49-F238E27FC236}">
-                <a16:creationId xmlns:a16="http://schemas.microsoft.com/office/drawing/2014/main" id="{E2C382DF-78B6-47DB-926E-9C035038724A}"/>
+                <a16:creationId xmlns:a16="http://schemas.microsoft.com/office/drawing/2014/main" id="{B841A3E7-EB45-4398-B79F-9878B5BEC6E4}"/>
               </a:ext>
             </a:extLst>
           </p:cNvPr>
@@ -9162,7 +9162,7 @@
           <p:cNvPr id="14" name="">
             <a:extLst xmlns:a="http://schemas.openxmlformats.org/drawingml/2006/main">
               <a:ext uri="{FF2B5EF4-FFF2-40B4-BE49-F238E27FC236}">
-                <a16:creationId xmlns:a16="http://schemas.microsoft.com/office/drawing/2014/main" id="{B6E2588F-7D4F-490B-ABDC-4AA9578B0F4B}"/>
+                <a16:creationId xmlns:a16="http://schemas.microsoft.com/office/drawing/2014/main" id="{BFC99329-1B9F-4669-BDBE-1C68A4E5F037}"/>
               </a:ext>
             </a:extLst>
           </p:cNvPr>
@@ -9203,7 +9203,7 @@
           <p:cNvPr id="15" name="">
             <a:extLst xmlns:a="http://schemas.openxmlformats.org/drawingml/2006/main">
               <a:ext uri="{FF2B5EF4-FFF2-40B4-BE49-F238E27FC236}">
-                <a16:creationId xmlns:a16="http://schemas.microsoft.com/office/drawing/2014/main" id="{6574FE63-0040-4C01-A5B6-C28EA30BE93F}"/>
+                <a16:creationId xmlns:a16="http://schemas.microsoft.com/office/drawing/2014/main" id="{AC4B25E2-0EAC-4693-9E1B-4B64D77DDE50}"/>
               </a:ext>
             </a:extLst>
           </p:cNvPr>
@@ -9253,7 +9253,7 @@
           <p:cNvPr id="16" name="">
             <a:extLst xmlns:a="http://schemas.openxmlformats.org/drawingml/2006/main">
               <a:ext uri="{FF2B5EF4-FFF2-40B4-BE49-F238E27FC236}">
-                <a16:creationId xmlns:a16="http://schemas.microsoft.com/office/drawing/2014/main" id="{0CA60E89-4732-40A8-B0E2-769F6246A742}"/>
+                <a16:creationId xmlns:a16="http://schemas.microsoft.com/office/drawing/2014/main" id="{D2201E2C-7919-43A3-8C2B-7890B26287A5}"/>
               </a:ext>
             </a:extLst>
           </p:cNvPr>
@@ -9303,7 +9303,7 @@
           <p:cNvPr id="17" name="">
             <a:extLst xmlns:a="http://schemas.openxmlformats.org/drawingml/2006/main">
               <a:ext uri="{FF2B5EF4-FFF2-40B4-BE49-F238E27FC236}">
-                <a16:creationId xmlns:a16="http://schemas.microsoft.com/office/drawing/2014/main" id="{5BC2CD7B-3F6F-412C-883E-6A8B3D7D3C22}"/>
+                <a16:creationId xmlns:a16="http://schemas.microsoft.com/office/drawing/2014/main" id="{BB43427E-EB04-46F9-AF23-C7D9630A8A60}"/>
               </a:ext>
             </a:extLst>
           </p:cNvPr>
@@ -9353,7 +9353,7 @@
           <p:cNvPr id="18" name="">
             <a:extLst xmlns:a="http://schemas.openxmlformats.org/drawingml/2006/main">
               <a:ext uri="{FF2B5EF4-FFF2-40B4-BE49-F238E27FC236}">
-                <a16:creationId xmlns:a16="http://schemas.microsoft.com/office/drawing/2014/main" id="{7F3D6D9F-D90B-46EC-95B4-452381CE4ED1}"/>
+                <a16:creationId xmlns:a16="http://schemas.microsoft.com/office/drawing/2014/main" id="{354227D2-155C-45CD-BC3B-C1B77132B708}"/>
               </a:ext>
             </a:extLst>
           </p:cNvPr>
@@ -9388,7 +9388,7 @@
           <p:cNvPr id="19" name="">
             <a:extLst xmlns:a="http://schemas.openxmlformats.org/drawingml/2006/main">
               <a:ext uri="{FF2B5EF4-FFF2-40B4-BE49-F238E27FC236}">
-                <a16:creationId xmlns:a16="http://schemas.microsoft.com/office/drawing/2014/main" id="{F558F8B3-3105-4690-8B20-4C3343A5B177}"/>
+                <a16:creationId xmlns:a16="http://schemas.microsoft.com/office/drawing/2014/main" id="{279F965C-9B22-431A-8E16-F2A6769536D1}"/>
               </a:ext>
             </a:extLst>
           </p:cNvPr>
@@ -9436,7 +9436,7 @@
     </p:spTree>
     <p:extLst>
       <p:ext uri="{BB962C8B-B14F-4D97-AF65-F5344CB8AC3E}">
-        <p14:creationId xmlns:p14="http://schemas.microsoft.com/office/powerpoint/2010/main" val="447128103"/>
+        <p14:creationId xmlns:p14="http://schemas.microsoft.com/office/powerpoint/2010/main" val="14563880"/>
       </p:ext>
     </p:extLst>
   </p:cSld>
@@ -9467,7 +9467,7 @@
           <p:cNvPr id="36" name="">
             <a:extLst xmlns:a="http://schemas.openxmlformats.org/drawingml/2006/main">
               <a:ext uri="{FF2B5EF4-FFF2-40B4-BE49-F238E27FC236}">
-                <a16:creationId xmlns:a16="http://schemas.microsoft.com/office/drawing/2014/main" id="{8DE1901C-D68D-4779-82E8-24E91399C97F}"/>
+                <a16:creationId xmlns:a16="http://schemas.microsoft.com/office/drawing/2014/main" id="{88619293-B49B-431A-9CED-D3AF9CE1087B}"/>
               </a:ext>
             </a:extLst>
           </p:cNvPr>
@@ -9523,7 +9523,7 @@
           <p:cNvPr id="2" name="">
             <a:extLst xmlns:a="http://schemas.openxmlformats.org/drawingml/2006/main">
               <a:ext uri="{FF2B5EF4-FFF2-40B4-BE49-F238E27FC236}">
-                <a16:creationId xmlns:a16="http://schemas.microsoft.com/office/drawing/2014/main" id="{7C966265-F85D-4018-BB6D-F31583480573}"/>
+                <a16:creationId xmlns:a16="http://schemas.microsoft.com/office/drawing/2014/main" id="{2904703A-9B86-4BD3-B2B9-A8D8E42A5A6B}"/>
               </a:ext>
             </a:extLst>
           </p:cNvPr>
@@ -9573,7 +9573,7 @@
           <p:cNvPr id="3" name="">
             <a:extLst xmlns:a="http://schemas.openxmlformats.org/drawingml/2006/main">
               <a:ext uri="{FF2B5EF4-FFF2-40B4-BE49-F238E27FC236}">
-                <a16:creationId xmlns:a16="http://schemas.microsoft.com/office/drawing/2014/main" id="{56B835A3-0A63-4D4C-AAE8-05CAB7DD3AE7}"/>
+                <a16:creationId xmlns:a16="http://schemas.microsoft.com/office/drawing/2014/main" id="{C10EA851-7BAD-4BBC-A60E-5383DBA1527D}"/>
               </a:ext>
             </a:extLst>
           </p:cNvPr>
@@ -9623,7 +9623,7 @@
           <p:cNvPr id="4" name="">
             <a:extLst xmlns:a="http://schemas.openxmlformats.org/drawingml/2006/main">
               <a:ext uri="{FF2B5EF4-FFF2-40B4-BE49-F238E27FC236}">
-                <a16:creationId xmlns:a16="http://schemas.microsoft.com/office/drawing/2014/main" id="{33927108-A90E-46E1-9657-6226CBCB638B}"/>
+                <a16:creationId xmlns:a16="http://schemas.microsoft.com/office/drawing/2014/main" id="{474D3725-0B64-47F9-B63C-9E1AF7CD6B85}"/>
               </a:ext>
             </a:extLst>
           </p:cNvPr>
@@ -9673,7 +9673,7 @@
           <p:cNvPr id="5" name="">
             <a:extLst xmlns:a="http://schemas.openxmlformats.org/drawingml/2006/main">
               <a:ext uri="{FF2B5EF4-FFF2-40B4-BE49-F238E27FC236}">
-                <a16:creationId xmlns:a16="http://schemas.microsoft.com/office/drawing/2014/main" id="{223BD696-CED7-4369-BEE6-41F4E33C2301}"/>
+                <a16:creationId xmlns:a16="http://schemas.microsoft.com/office/drawing/2014/main" id="{39307B7F-AE45-4C8B-A363-786F2617BC92}"/>
               </a:ext>
             </a:extLst>
           </p:cNvPr>
@@ -9723,7 +9723,7 @@
           <p:cNvPr id="6" name="">
             <a:extLst xmlns:a="http://schemas.openxmlformats.org/drawingml/2006/main">
               <a:ext uri="{FF2B5EF4-FFF2-40B4-BE49-F238E27FC236}">
-                <a16:creationId xmlns:a16="http://schemas.microsoft.com/office/drawing/2014/main" id="{00512D08-1652-46A8-A619-F04EEF85B12A}"/>
+                <a16:creationId xmlns:a16="http://schemas.microsoft.com/office/drawing/2014/main" id="{FC8D6244-FE73-4200-B6DF-EDEA6D409E5A}"/>
               </a:ext>
             </a:extLst>
           </p:cNvPr>
@@ -9764,7 +9764,7 @@
           <p:cNvPr id="7" name="">
             <a:extLst xmlns:a="http://schemas.openxmlformats.org/drawingml/2006/main">
               <a:ext uri="{FF2B5EF4-FFF2-40B4-BE49-F238E27FC236}">
-                <a16:creationId xmlns:a16="http://schemas.microsoft.com/office/drawing/2014/main" id="{567286B4-2587-42F6-8CAD-CE113E4ECBAF}"/>
+                <a16:creationId xmlns:a16="http://schemas.microsoft.com/office/drawing/2014/main" id="{B509139C-993D-4ED6-80FF-D9EC70FD7746}"/>
               </a:ext>
             </a:extLst>
           </p:cNvPr>
@@ -9799,7 +9799,7 @@
           <p:cNvPr id="8" name="">
             <a:extLst xmlns:a="http://schemas.openxmlformats.org/drawingml/2006/main">
               <a:ext uri="{FF2B5EF4-FFF2-40B4-BE49-F238E27FC236}">
-                <a16:creationId xmlns:a16="http://schemas.microsoft.com/office/drawing/2014/main" id="{769860A8-FE1E-47B7-B2A2-15355C2A9B7C}"/>
+                <a16:creationId xmlns:a16="http://schemas.microsoft.com/office/drawing/2014/main" id="{755C4C54-A05C-4EBF-ABF3-B89AC8276407}"/>
               </a:ext>
             </a:extLst>
           </p:cNvPr>
@@ -9849,7 +9849,7 @@
           <p:cNvPr id="9" name="">
             <a:extLst xmlns:a="http://schemas.openxmlformats.org/drawingml/2006/main">
               <a:ext uri="{FF2B5EF4-FFF2-40B4-BE49-F238E27FC236}">
-                <a16:creationId xmlns:a16="http://schemas.microsoft.com/office/drawing/2014/main" id="{3E9E54C6-C6DC-4350-8C24-AD4DF5BA54CB}"/>
+                <a16:creationId xmlns:a16="http://schemas.microsoft.com/office/drawing/2014/main" id="{FB3FAAFA-A132-40D4-8BF4-019E446C86BB}"/>
               </a:ext>
             </a:extLst>
           </p:cNvPr>
@@ -9899,7 +9899,7 @@
           <p:cNvPr id="10" name="">
             <a:extLst xmlns:a="http://schemas.openxmlformats.org/drawingml/2006/main">
               <a:ext uri="{FF2B5EF4-FFF2-40B4-BE49-F238E27FC236}">
-                <a16:creationId xmlns:a16="http://schemas.microsoft.com/office/drawing/2014/main" id="{1B9AD8FF-1E2D-44AD-90C7-22E86E546378}"/>
+                <a16:creationId xmlns:a16="http://schemas.microsoft.com/office/drawing/2014/main" id="{6543D227-8D73-44FC-9AAE-F81A75D25174}"/>
               </a:ext>
             </a:extLst>
           </p:cNvPr>
@@ -9949,7 +9949,7 @@
           <p:cNvPr id="11" name="">
             <a:extLst xmlns:a="http://schemas.openxmlformats.org/drawingml/2006/main">
               <a:ext uri="{FF2B5EF4-FFF2-40B4-BE49-F238E27FC236}">
-                <a16:creationId xmlns:a16="http://schemas.microsoft.com/office/drawing/2014/main" id="{81C29A6B-5E62-4035-83CE-45C79788C1AD}"/>
+                <a16:creationId xmlns:a16="http://schemas.microsoft.com/office/drawing/2014/main" id="{1F6F41CC-3BDF-4BA2-B8CC-F449376C2B9E}"/>
               </a:ext>
             </a:extLst>
           </p:cNvPr>
@@ -9990,7 +9990,7 @@
           <p:cNvPr id="12" name="">
             <a:extLst xmlns:a="http://schemas.openxmlformats.org/drawingml/2006/main">
               <a:ext uri="{FF2B5EF4-FFF2-40B4-BE49-F238E27FC236}">
-                <a16:creationId xmlns:a16="http://schemas.microsoft.com/office/drawing/2014/main" id="{CB63B790-20DF-497D-8E56-A0A735CE6450}"/>
+                <a16:creationId xmlns:a16="http://schemas.microsoft.com/office/drawing/2014/main" id="{3683C25C-F672-4E06-99A2-0B3B22B49D52}"/>
               </a:ext>
             </a:extLst>
           </p:cNvPr>
@@ -10025,7 +10025,7 @@
           <p:cNvPr id="13" name="">
             <a:extLst xmlns:a="http://schemas.openxmlformats.org/drawingml/2006/main">
               <a:ext uri="{FF2B5EF4-FFF2-40B4-BE49-F238E27FC236}">
-                <a16:creationId xmlns:a16="http://schemas.microsoft.com/office/drawing/2014/main" id="{F4EB0E86-264D-4537-BD18-C15CA1691EDA}"/>
+                <a16:creationId xmlns:a16="http://schemas.microsoft.com/office/drawing/2014/main" id="{CFB0642A-BE55-4C13-8BA1-AC0D167BDE27}"/>
               </a:ext>
             </a:extLst>
           </p:cNvPr>
@@ -10075,7 +10075,7 @@
           <p:cNvPr id="14" name="">
             <a:extLst xmlns:a="http://schemas.openxmlformats.org/drawingml/2006/main">
               <a:ext uri="{FF2B5EF4-FFF2-40B4-BE49-F238E27FC236}">
-                <a16:creationId xmlns:a16="http://schemas.microsoft.com/office/drawing/2014/main" id="{14D854C3-66BF-46D4-ADAD-BFAF7137EB42}"/>
+                <a16:creationId xmlns:a16="http://schemas.microsoft.com/office/drawing/2014/main" id="{589A7387-ADE4-4287-8E97-21BCE09C23CC}"/>
               </a:ext>
             </a:extLst>
           </p:cNvPr>
@@ -10125,7 +10125,7 @@
           <p:cNvPr id="15" name="">
             <a:extLst xmlns:a="http://schemas.openxmlformats.org/drawingml/2006/main">
               <a:ext uri="{FF2B5EF4-FFF2-40B4-BE49-F238E27FC236}">
-                <a16:creationId xmlns:a16="http://schemas.microsoft.com/office/drawing/2014/main" id="{DD5E61A5-C5E2-48D7-895E-84E7B1B0A06D}"/>
+                <a16:creationId xmlns:a16="http://schemas.microsoft.com/office/drawing/2014/main" id="{E56E5B53-F419-4E7F-B7B0-C7A6C721F1DD}"/>
               </a:ext>
             </a:extLst>
           </p:cNvPr>
@@ -10175,7 +10175,7 @@
           <p:cNvPr id="16" name="">
             <a:extLst xmlns:a="http://schemas.openxmlformats.org/drawingml/2006/main">
               <a:ext uri="{FF2B5EF4-FFF2-40B4-BE49-F238E27FC236}">
-                <a16:creationId xmlns:a16="http://schemas.microsoft.com/office/drawing/2014/main" id="{16C29210-1A9C-4E68-88ED-447DF17DF66C}"/>
+                <a16:creationId xmlns:a16="http://schemas.microsoft.com/office/drawing/2014/main" id="{A62DDE45-DA95-426A-B1AD-DAA6F04985D6}"/>
               </a:ext>
             </a:extLst>
           </p:cNvPr>
@@ -10216,7 +10216,7 @@
           <p:cNvPr id="17" name="">
             <a:extLst xmlns:a="http://schemas.openxmlformats.org/drawingml/2006/main">
               <a:ext uri="{FF2B5EF4-FFF2-40B4-BE49-F238E27FC236}">
-                <a16:creationId xmlns:a16="http://schemas.microsoft.com/office/drawing/2014/main" id="{C26D4531-1B24-47AF-BF21-06AF55B9C256}"/>
+                <a16:creationId xmlns:a16="http://schemas.microsoft.com/office/drawing/2014/main" id="{31FF74E4-70CF-42D8-B391-D6A60D33CE3E}"/>
               </a:ext>
             </a:extLst>
           </p:cNvPr>
@@ -10251,7 +10251,7 @@
           <p:cNvPr id="18" name="">
             <a:extLst xmlns:a="http://schemas.openxmlformats.org/drawingml/2006/main">
               <a:ext uri="{FF2B5EF4-FFF2-40B4-BE49-F238E27FC236}">
-                <a16:creationId xmlns:a16="http://schemas.microsoft.com/office/drawing/2014/main" id="{FBF0D191-28D8-46E0-9B4D-37BCB113C8FE}"/>
+                <a16:creationId xmlns:a16="http://schemas.microsoft.com/office/drawing/2014/main" id="{FEDD0FAB-7F0F-4791-8038-D7A1C8B78321}"/>
               </a:ext>
             </a:extLst>
           </p:cNvPr>
@@ -10301,7 +10301,7 @@
           <p:cNvPr id="19" name="">
             <a:extLst xmlns:a="http://schemas.openxmlformats.org/drawingml/2006/main">
               <a:ext uri="{FF2B5EF4-FFF2-40B4-BE49-F238E27FC236}">
-                <a16:creationId xmlns:a16="http://schemas.microsoft.com/office/drawing/2014/main" id="{C77F80B1-9E8C-4E2E-AF19-650C066BA5DD}"/>
+                <a16:creationId xmlns:a16="http://schemas.microsoft.com/office/drawing/2014/main" id="{8040A7E2-3BE2-42F9-B98B-148099A3E203}"/>
               </a:ext>
             </a:extLst>
           </p:cNvPr>
@@ -10351,7 +10351,7 @@
           <p:cNvPr id="20" name="">
             <a:extLst xmlns:a="http://schemas.openxmlformats.org/drawingml/2006/main">
               <a:ext uri="{FF2B5EF4-FFF2-40B4-BE49-F238E27FC236}">
-                <a16:creationId xmlns:a16="http://schemas.microsoft.com/office/drawing/2014/main" id="{DE33F0BE-1A9D-462E-BEC1-9622B3ECCC44}"/>
+                <a16:creationId xmlns:a16="http://schemas.microsoft.com/office/drawing/2014/main" id="{BB91740C-CF36-4448-AB53-EBCF0D8A3659}"/>
               </a:ext>
             </a:extLst>
           </p:cNvPr>
@@ -10401,7 +10401,7 @@
           <p:cNvPr id="21" name="">
             <a:extLst xmlns:a="http://schemas.openxmlformats.org/drawingml/2006/main">
               <a:ext uri="{FF2B5EF4-FFF2-40B4-BE49-F238E27FC236}">
-                <a16:creationId xmlns:a16="http://schemas.microsoft.com/office/drawing/2014/main" id="{7FDBE7A7-EFBE-4051-82E8-FF3D9555BB05}"/>
+                <a16:creationId xmlns:a16="http://schemas.microsoft.com/office/drawing/2014/main" id="{49B18E60-1236-41CA-8D3D-2AD86B9ED23E}"/>
               </a:ext>
             </a:extLst>
           </p:cNvPr>
@@ -10442,7 +10442,7 @@
           <p:cNvPr id="22" name="">
             <a:extLst xmlns:a="http://schemas.openxmlformats.org/drawingml/2006/main">
               <a:ext uri="{FF2B5EF4-FFF2-40B4-BE49-F238E27FC236}">
-                <a16:creationId xmlns:a16="http://schemas.microsoft.com/office/drawing/2014/main" id="{BA4299A8-0166-4B08-B4F2-B4A45A663AEA}"/>
+                <a16:creationId xmlns:a16="http://schemas.microsoft.com/office/drawing/2014/main" id="{DCE84865-5B6D-489C-9BB3-C72BA8582B1E}"/>
               </a:ext>
             </a:extLst>
           </p:cNvPr>
@@ -10477,7 +10477,7 @@
           <p:cNvPr id="23" name="">
             <a:extLst xmlns:a="http://schemas.openxmlformats.org/drawingml/2006/main">
               <a:ext uri="{FF2B5EF4-FFF2-40B4-BE49-F238E27FC236}">
-                <a16:creationId xmlns:a16="http://schemas.microsoft.com/office/drawing/2014/main" id="{471F2FB3-C4EE-47B0-B05E-EC06274EDE3C}"/>
+                <a16:creationId xmlns:a16="http://schemas.microsoft.com/office/drawing/2014/main" id="{A5D68EBA-2BF4-41F2-BA96-AB58E60DA07E}"/>
               </a:ext>
             </a:extLst>
           </p:cNvPr>
@@ -10527,7 +10527,7 @@
           <p:cNvPr id="24" name="">
             <a:extLst xmlns:a="http://schemas.openxmlformats.org/drawingml/2006/main">
               <a:ext uri="{FF2B5EF4-FFF2-40B4-BE49-F238E27FC236}">
-                <a16:creationId xmlns:a16="http://schemas.microsoft.com/office/drawing/2014/main" id="{9B27B1EA-7955-472D-9B9A-574EA12BA518}"/>
+                <a16:creationId xmlns:a16="http://schemas.microsoft.com/office/drawing/2014/main" id="{97700B5A-8DB7-4F48-A47F-DCDC1E9B2E4B}"/>
               </a:ext>
             </a:extLst>
           </p:cNvPr>
@@ -10577,7 +10577,7 @@
           <p:cNvPr id="25" name="">
             <a:extLst xmlns:a="http://schemas.openxmlformats.org/drawingml/2006/main">
               <a:ext uri="{FF2B5EF4-FFF2-40B4-BE49-F238E27FC236}">
-                <a16:creationId xmlns:a16="http://schemas.microsoft.com/office/drawing/2014/main" id="{97DF12C3-B021-4CC1-ABCA-8873593094F7}"/>
+                <a16:creationId xmlns:a16="http://schemas.microsoft.com/office/drawing/2014/main" id="{734A9777-D78E-4193-BB81-FE4A996AE359}"/>
               </a:ext>
             </a:extLst>
           </p:cNvPr>
@@ -10627,7 +10627,7 @@
           <p:cNvPr id="26" name="">
             <a:extLst xmlns:a="http://schemas.openxmlformats.org/drawingml/2006/main">
               <a:ext uri="{FF2B5EF4-FFF2-40B4-BE49-F238E27FC236}">
-                <a16:creationId xmlns:a16="http://schemas.microsoft.com/office/drawing/2014/main" id="{EB7ABFED-C4E8-4E2E-9A02-D78F2EAEE53B}"/>
+                <a16:creationId xmlns:a16="http://schemas.microsoft.com/office/drawing/2014/main" id="{C6D1A8A6-5063-4116-A222-57BCCF16D2D9}"/>
               </a:ext>
             </a:extLst>
           </p:cNvPr>
@@ -10668,7 +10668,7 @@
           <p:cNvPr id="27" name="">
             <a:extLst xmlns:a="http://schemas.openxmlformats.org/drawingml/2006/main">
               <a:ext uri="{FF2B5EF4-FFF2-40B4-BE49-F238E27FC236}">
-                <a16:creationId xmlns:a16="http://schemas.microsoft.com/office/drawing/2014/main" id="{D8B113FC-1FA5-4157-B739-5C20E4A73443}"/>
+                <a16:creationId xmlns:a16="http://schemas.microsoft.com/office/drawing/2014/main" id="{5095A016-FD04-417E-93CC-83F05C062CFA}"/>
               </a:ext>
             </a:extLst>
           </p:cNvPr>
@@ -10703,7 +10703,7 @@
           <p:cNvPr id="28" name="">
             <a:extLst xmlns:a="http://schemas.openxmlformats.org/drawingml/2006/main">
               <a:ext uri="{FF2B5EF4-FFF2-40B4-BE49-F238E27FC236}">
-                <a16:creationId xmlns:a16="http://schemas.microsoft.com/office/drawing/2014/main" id="{34B85F1C-53B3-45E5-87DC-8B812A2B634D}"/>
+                <a16:creationId xmlns:a16="http://schemas.microsoft.com/office/drawing/2014/main" id="{78212C9D-0B46-46BD-AEBF-E5699096F990}"/>
               </a:ext>
             </a:extLst>
           </p:cNvPr>
@@ -10753,7 +10753,7 @@
           <p:cNvPr id="29" name="">
             <a:extLst xmlns:a="http://schemas.openxmlformats.org/drawingml/2006/main">
               <a:ext uri="{FF2B5EF4-FFF2-40B4-BE49-F238E27FC236}">
-                <a16:creationId xmlns:a16="http://schemas.microsoft.com/office/drawing/2014/main" id="{F8EB21AD-47F4-46E6-85B8-804C1C12D8EA}"/>
+                <a16:creationId xmlns:a16="http://schemas.microsoft.com/office/drawing/2014/main" id="{BCE2BDD8-874F-42D9-A0FF-4FA608C5FBE8}"/>
               </a:ext>
             </a:extLst>
           </p:cNvPr>
@@ -10803,7 +10803,7 @@
           <p:cNvPr id="30" name="">
             <a:extLst xmlns:a="http://schemas.openxmlformats.org/drawingml/2006/main">
               <a:ext uri="{FF2B5EF4-FFF2-40B4-BE49-F238E27FC236}">
-                <a16:creationId xmlns:a16="http://schemas.microsoft.com/office/drawing/2014/main" id="{E81BC6B2-2A70-4F9A-B424-003874F71BF0}"/>
+                <a16:creationId xmlns:a16="http://schemas.microsoft.com/office/drawing/2014/main" id="{B88746D4-C484-4CB6-BCF0-7538F3F258A6}"/>
               </a:ext>
             </a:extLst>
           </p:cNvPr>
@@ -10870,7 +10870,7 @@
               <a:srgbClr val="3D8DFF"/>
             </a:solidFill>
             <a:prstDash val="solid"/>
-            <a:headEnd type="arrow" w="sm" len="sm"/>
+            <a:tailEnd type="arrow" w="sm" len="sm"/>
           </a:ln>
         </p:spPr>
       </p:cxnSp>
@@ -10896,7 +10896,7 @@
               <a:srgbClr val="3D8DFF"/>
             </a:solidFill>
             <a:prstDash val="solid"/>
-            <a:headEnd type="arrow" w="sm" len="sm"/>
+            <a:tailEnd type="arrow" w="sm" len="sm"/>
           </a:ln>
         </p:spPr>
       </p:cxnSp>
@@ -10922,7 +10922,7 @@
               <a:srgbClr val="3D8DFF"/>
             </a:solidFill>
             <a:prstDash val="solid"/>
-            <a:headEnd type="arrow" w="sm" len="sm"/>
+            <a:tailEnd type="arrow" w="sm" len="sm"/>
           </a:ln>
         </p:spPr>
       </p:cxnSp>
@@ -10948,7 +10948,7 @@
               <a:srgbClr val="3D8DFF"/>
             </a:solidFill>
             <a:prstDash val="solid"/>
-            <a:headEnd type="arrow" w="sm" len="sm"/>
+            <a:tailEnd type="arrow" w="sm" len="sm"/>
           </a:ln>
         </p:spPr>
       </p:cxnSp>
@@ -10957,7 +10957,7 @@
           <p:cNvPr id="35" name="">
             <a:extLst xmlns:a="http://schemas.openxmlformats.org/drawingml/2006/main">
               <a:ext uri="{FF2B5EF4-FFF2-40B4-BE49-F238E27FC236}">
-                <a16:creationId xmlns:a16="http://schemas.microsoft.com/office/drawing/2014/main" id="{716C6DE1-C240-411B-872B-87C6D5EED539}"/>
+                <a16:creationId xmlns:a16="http://schemas.microsoft.com/office/drawing/2014/main" id="{E721D4E3-3DEF-4536-8554-17A772A028C8}"/>
               </a:ext>
             </a:extLst>
           </p:cNvPr>
@@ -11005,7 +11005,7 @@
     </p:spTree>
     <p:extLst>
       <p:ext uri="{BB962C8B-B14F-4D97-AF65-F5344CB8AC3E}">
-        <p14:creationId xmlns:p14="http://schemas.microsoft.com/office/powerpoint/2010/main" val="765123673"/>
+        <p14:creationId xmlns:p14="http://schemas.microsoft.com/office/powerpoint/2010/main" val="1567997126"/>
       </p:ext>
     </p:extLst>
   </p:cSld>
@@ -11036,7 +11036,7 @@
           <p:cNvPr id="13" name="">
             <a:extLst xmlns:a="http://schemas.openxmlformats.org/drawingml/2006/main">
               <a:ext uri="{FF2B5EF4-FFF2-40B4-BE49-F238E27FC236}">
-                <a16:creationId xmlns:a16="http://schemas.microsoft.com/office/drawing/2014/main" id="{A1E455EF-F604-4AF3-BEAA-16136E847336}"/>
+                <a16:creationId xmlns:a16="http://schemas.microsoft.com/office/drawing/2014/main" id="{49D6D01A-DBE1-4EBF-ABA3-B8F85DEB4E2E}"/>
               </a:ext>
             </a:extLst>
           </p:cNvPr>
@@ -11092,7 +11092,7 @@
           <p:cNvPr id="2" name="">
             <a:extLst xmlns:a="http://schemas.openxmlformats.org/drawingml/2006/main">
               <a:ext uri="{FF2B5EF4-FFF2-40B4-BE49-F238E27FC236}">
-                <a16:creationId xmlns:a16="http://schemas.microsoft.com/office/drawing/2014/main" id="{AB4BC46D-36BC-49BB-91B1-F06C777B5FDB}"/>
+                <a16:creationId xmlns:a16="http://schemas.microsoft.com/office/drawing/2014/main" id="{2B22F8F8-237C-4974-81B2-1C19E2D8F63D}"/>
               </a:ext>
             </a:extLst>
           </p:cNvPr>
@@ -11159,7 +11159,7 @@
           <p:cNvPr id="3" name="">
             <a:extLst xmlns:a="http://schemas.openxmlformats.org/drawingml/2006/main">
               <a:ext uri="{FF2B5EF4-FFF2-40B4-BE49-F238E27FC236}">
-                <a16:creationId xmlns:a16="http://schemas.microsoft.com/office/drawing/2014/main" id="{4608369B-D015-4375-A069-5BD9DCC3522C}"/>
+                <a16:creationId xmlns:a16="http://schemas.microsoft.com/office/drawing/2014/main" id="{825043C2-D526-4A08-9267-835AA7EC83EF}"/>
               </a:ext>
             </a:extLst>
           </p:cNvPr>
@@ -11194,7 +11194,7 @@
           <p:cNvPr id="4" name="">
             <a:extLst xmlns:a="http://schemas.openxmlformats.org/drawingml/2006/main">
               <a:ext uri="{FF2B5EF4-FFF2-40B4-BE49-F238E27FC236}">
-                <a16:creationId xmlns:a16="http://schemas.microsoft.com/office/drawing/2014/main" id="{C401CE6D-4333-405D-B39A-DD92011AB9CE}"/>
+                <a16:creationId xmlns:a16="http://schemas.microsoft.com/office/drawing/2014/main" id="{1AABE7D7-0215-436A-8DB0-06133108F910}"/>
               </a:ext>
             </a:extLst>
           </p:cNvPr>
@@ -11244,7 +11244,7 @@
           <p:cNvPr id="5" name="">
             <a:extLst xmlns:a="http://schemas.openxmlformats.org/drawingml/2006/main">
               <a:ext uri="{FF2B5EF4-FFF2-40B4-BE49-F238E27FC236}">
-                <a16:creationId xmlns:a16="http://schemas.microsoft.com/office/drawing/2014/main" id="{96A9B882-61AA-4277-AE36-C316BC433259}"/>
+                <a16:creationId xmlns:a16="http://schemas.microsoft.com/office/drawing/2014/main" id="{9F2CA0D0-D40B-4F2A-B983-A88A5C62E138}"/>
               </a:ext>
             </a:extLst>
           </p:cNvPr>
@@ -11294,7 +11294,7 @@
           <p:cNvPr id="6" name="">
             <a:extLst xmlns:a="http://schemas.openxmlformats.org/drawingml/2006/main">
               <a:ext uri="{FF2B5EF4-FFF2-40B4-BE49-F238E27FC236}">
-                <a16:creationId xmlns:a16="http://schemas.microsoft.com/office/drawing/2014/main" id="{E9D404A2-44A0-4264-B9D9-7B5BB875E530}"/>
+                <a16:creationId xmlns:a16="http://schemas.microsoft.com/office/drawing/2014/main" id="{049B535C-7922-426E-AB25-9265C468C417}"/>
               </a:ext>
             </a:extLst>
           </p:cNvPr>
@@ -11329,7 +11329,7 @@
           <p:cNvPr id="7" name="">
             <a:extLst xmlns:a="http://schemas.openxmlformats.org/drawingml/2006/main">
               <a:ext uri="{FF2B5EF4-FFF2-40B4-BE49-F238E27FC236}">
-                <a16:creationId xmlns:a16="http://schemas.microsoft.com/office/drawing/2014/main" id="{AC091F33-FB82-4012-83F2-8B14C78D9CDD}"/>
+                <a16:creationId xmlns:a16="http://schemas.microsoft.com/office/drawing/2014/main" id="{696D1E63-2FB8-47D3-AD77-6BCF21B16C55}"/>
               </a:ext>
             </a:extLst>
           </p:cNvPr>
@@ -11379,7 +11379,7 @@
           <p:cNvPr id="8" name="">
             <a:extLst xmlns:a="http://schemas.openxmlformats.org/drawingml/2006/main">
               <a:ext uri="{FF2B5EF4-FFF2-40B4-BE49-F238E27FC236}">
-                <a16:creationId xmlns:a16="http://schemas.microsoft.com/office/drawing/2014/main" id="{8F8BECE5-6219-4984-AEC5-F7FFF4FF47C1}"/>
+                <a16:creationId xmlns:a16="http://schemas.microsoft.com/office/drawing/2014/main" id="{A8E94AE6-5BFB-4837-85D2-814E74D1E068}"/>
               </a:ext>
             </a:extLst>
           </p:cNvPr>
@@ -11429,7 +11429,7 @@
           <p:cNvPr id="9" name="">
             <a:extLst xmlns:a="http://schemas.openxmlformats.org/drawingml/2006/main">
               <a:ext uri="{FF2B5EF4-FFF2-40B4-BE49-F238E27FC236}">
-                <a16:creationId xmlns:a16="http://schemas.microsoft.com/office/drawing/2014/main" id="{D1349DA0-2862-49B5-8208-96FE5416482D}"/>
+                <a16:creationId xmlns:a16="http://schemas.microsoft.com/office/drawing/2014/main" id="{F4C956A9-2B09-49C6-8CDB-36BAF27B19CE}"/>
               </a:ext>
             </a:extLst>
           </p:cNvPr>
@@ -11464,7 +11464,7 @@
           <p:cNvPr id="10" name="">
             <a:extLst xmlns:a="http://schemas.openxmlformats.org/drawingml/2006/main">
               <a:ext uri="{FF2B5EF4-FFF2-40B4-BE49-F238E27FC236}">
-                <a16:creationId xmlns:a16="http://schemas.microsoft.com/office/drawing/2014/main" id="{AF834F47-7F76-49E3-A716-636A79284C15}"/>
+                <a16:creationId xmlns:a16="http://schemas.microsoft.com/office/drawing/2014/main" id="{20123857-3BAA-43A9-BEF0-F1198EA08A97}"/>
               </a:ext>
             </a:extLst>
           </p:cNvPr>
@@ -11514,7 +11514,7 @@
           <p:cNvPr id="11" name="">
             <a:extLst xmlns:a="http://schemas.openxmlformats.org/drawingml/2006/main">
               <a:ext uri="{FF2B5EF4-FFF2-40B4-BE49-F238E27FC236}">
-                <a16:creationId xmlns:a16="http://schemas.microsoft.com/office/drawing/2014/main" id="{651F134A-281D-4FAA-82CD-48282F7C6746}"/>
+                <a16:creationId xmlns:a16="http://schemas.microsoft.com/office/drawing/2014/main" id="{A5B310AE-56E7-4BE5-B163-6F9558ED5219}"/>
               </a:ext>
             </a:extLst>
           </p:cNvPr>
@@ -11564,7 +11564,7 @@
           <p:cNvPr id="12" name="">
             <a:extLst xmlns:a="http://schemas.openxmlformats.org/drawingml/2006/main">
               <a:ext uri="{FF2B5EF4-FFF2-40B4-BE49-F238E27FC236}">
-                <a16:creationId xmlns:a16="http://schemas.microsoft.com/office/drawing/2014/main" id="{059CAE10-355B-4C5E-AD09-6D7DFECC0605}"/>
+                <a16:creationId xmlns:a16="http://schemas.microsoft.com/office/drawing/2014/main" id="{4A5FF0B1-AB11-4107-8EE6-001AE773BB9E}"/>
               </a:ext>
             </a:extLst>
           </p:cNvPr>
@@ -11612,7 +11612,7 @@
     </p:spTree>
     <p:extLst>
       <p:ext uri="{BB962C8B-B14F-4D97-AF65-F5344CB8AC3E}">
-        <p14:creationId xmlns:p14="http://schemas.microsoft.com/office/powerpoint/2010/main" val="1541505753"/>
+        <p14:creationId xmlns:p14="http://schemas.microsoft.com/office/powerpoint/2010/main" val="1378848030"/>
       </p:ext>
     </p:extLst>
   </p:cSld>

</xml_diff>